<commit_message>
chore: francisation des libelles (Demande d'infos sup, panneau-demande-infos-sup) et DPI (Data Process et Innovation)
</commit_message>
<xml_diff>
--- a/Presentation_Developpement_Plugin_Jira_DataCenter.pptx
+++ b/Presentation_Developpement_Plugin_Jira_DataCenter.pptx
@@ -220,9 +220,9 @@
             </a:lvl1pPr>
           </a:lstStyle>
           <a:p>
-            <a:fld id="{E86EC531-E91B-42F1-AB80-5457A68AE7AA}" type="datetimeFigureOut">
+            <a:fld id="{8FBD03C3-2687-4BAC-8E46-4DC683F3A190}" type="datetimeFigureOut">
               <a:rPr lang="en-US" smtClean="0"/>
-              <a:t>10/27/2026</a:t>
+              <a:t>10/30/2026</a:t>
             </a:fld>
             <a:endParaRPr lang="en-US"/>
           </a:p>
@@ -379,7 +379,7 @@
             </a:lvl1pPr>
           </a:lstStyle>
           <a:p>
-            <a:fld id="{43CA2844-41C6-4F73-8CE2-E5A99E201805}" type="slidenum">
+            <a:fld id="{AA8A2905-1E39-4DE1-BA8A-2348BBA85102}" type="slidenum">
               <a:rPr lang="en-US" smtClean="0"/>
               <a:t>‹N°›</a:t>
             </a:fld>
@@ -390,7 +390,7 @@
     </p:spTree>
     <p:extLst>
       <p:ext uri="{BB962C8B-B14F-4D97-AF65-F5344CB8AC3E}">
-        <p14:creationId xmlns:p14="http://schemas.microsoft.com/office/powerpoint/2010/main" val="2521628428"/>
+        <p14:creationId xmlns:p14="http://schemas.microsoft.com/office/powerpoint/2010/main" val="2170586476"/>
       </p:ext>
     </p:extLst>
   </p:cSld>
@@ -557,7 +557,7 @@
           <a:bodyPr/>
           <a:lstStyle/>
           <a:p>
-            <a:fld id="{43CA2844-41C6-4F73-8CE2-E5A99E201805}" type="slidenum">
+            <a:fld id="{AA8A2905-1E39-4DE1-BA8A-2348BBA85102}" type="slidenum">
               <a:rPr lang="en-US" smtClean="0"/>
               <a:t>1</a:t>
             </a:fld>
@@ -568,7 +568,7 @@
     </p:spTree>
     <p:extLst>
       <p:ext uri="{BB962C8B-B14F-4D97-AF65-F5344CB8AC3E}">
-        <p14:creationId xmlns:p14="http://schemas.microsoft.com/office/powerpoint/2010/main" val="3971553834"/>
+        <p14:creationId xmlns:p14="http://schemas.microsoft.com/office/powerpoint/2010/main" val="3114595803"/>
       </p:ext>
     </p:extLst>
   </p:cSld>
@@ -645,7 +645,7 @@
           <a:bodyPr/>
           <a:lstStyle/>
           <a:p>
-            <a:fld id="{43CA2844-41C6-4F73-8CE2-E5A99E201805}" type="slidenum">
+            <a:fld id="{AA8A2905-1E39-4DE1-BA8A-2348BBA85102}" type="slidenum">
               <a:rPr lang="en-US" smtClean="0"/>
               <a:t>26</a:t>
             </a:fld>
@@ -656,7 +656,7 @@
     </p:spTree>
     <p:extLst>
       <p:ext uri="{BB962C8B-B14F-4D97-AF65-F5344CB8AC3E}">
-        <p14:creationId xmlns:p14="http://schemas.microsoft.com/office/powerpoint/2010/main" val="791884370"/>
+        <p14:creationId xmlns:p14="http://schemas.microsoft.com/office/powerpoint/2010/main" val="1666299714"/>
       </p:ext>
     </p:extLst>
   </p:cSld>
@@ -712,7 +712,7 @@
           <a:p>
             <a:r>
               <a:rPr lang="fr-FR" smtClean="0"/>
-              <a:t>Démonstration pas à pas de la création d'une demande de précision par l'assigné du ticket.</a:t>
+              <a:t>Démonstration pas à pas de la création d'une demande d'informations supplémentaires par l'assigné du ticket.</a:t>
             </a:r>
             <a:endParaRPr lang="en-US"/>
           </a:p>
@@ -733,7 +733,7 @@
           <a:bodyPr/>
           <a:lstStyle/>
           <a:p>
-            <a:fld id="{43CA2844-41C6-4F73-8CE2-E5A99E201805}" type="slidenum">
+            <a:fld id="{AA8A2905-1E39-4DE1-BA8A-2348BBA85102}" type="slidenum">
               <a:rPr lang="en-US" smtClean="0"/>
               <a:t>27</a:t>
             </a:fld>
@@ -744,7 +744,7 @@
     </p:spTree>
     <p:extLst>
       <p:ext uri="{BB962C8B-B14F-4D97-AF65-F5344CB8AC3E}">
-        <p14:creationId xmlns:p14="http://schemas.microsoft.com/office/powerpoint/2010/main" val="3097198685"/>
+        <p14:creationId xmlns:p14="http://schemas.microsoft.com/office/powerpoint/2010/main" val="2499241202"/>
       </p:ext>
     </p:extLst>
   </p:cSld>
@@ -821,7 +821,7 @@
           <a:bodyPr/>
           <a:lstStyle/>
           <a:p>
-            <a:fld id="{43CA2844-41C6-4F73-8CE2-E5A99E201805}" type="slidenum">
+            <a:fld id="{AA8A2905-1E39-4DE1-BA8A-2348BBA85102}" type="slidenum">
               <a:rPr lang="en-US" smtClean="0"/>
               <a:t>28</a:t>
             </a:fld>
@@ -832,7 +832,7 @@
     </p:spTree>
     <p:extLst>
       <p:ext uri="{BB962C8B-B14F-4D97-AF65-F5344CB8AC3E}">
-        <p14:creationId xmlns:p14="http://schemas.microsoft.com/office/powerpoint/2010/main" val="111965222"/>
+        <p14:creationId xmlns:p14="http://schemas.microsoft.com/office/powerpoint/2010/main" val="3957265131"/>
       </p:ext>
     </p:extLst>
   </p:cSld>
@@ -909,7 +909,7 @@
           <a:bodyPr/>
           <a:lstStyle/>
           <a:p>
-            <a:fld id="{43CA2844-41C6-4F73-8CE2-E5A99E201805}" type="slidenum">
+            <a:fld id="{AA8A2905-1E39-4DE1-BA8A-2348BBA85102}" type="slidenum">
               <a:rPr lang="en-US" smtClean="0"/>
               <a:t>2</a:t>
             </a:fld>
@@ -920,7 +920,7 @@
     </p:spTree>
     <p:extLst>
       <p:ext uri="{BB962C8B-B14F-4D97-AF65-F5344CB8AC3E}">
-        <p14:creationId xmlns:p14="http://schemas.microsoft.com/office/powerpoint/2010/main" val="2204789642"/>
+        <p14:creationId xmlns:p14="http://schemas.microsoft.com/office/powerpoint/2010/main" val="1333088354"/>
       </p:ext>
     </p:extLst>
   </p:cSld>
@@ -997,7 +997,7 @@
           <a:bodyPr/>
           <a:lstStyle/>
           <a:p>
-            <a:fld id="{43CA2844-41C6-4F73-8CE2-E5A99E201805}" type="slidenum">
+            <a:fld id="{AA8A2905-1E39-4DE1-BA8A-2348BBA85102}" type="slidenum">
               <a:rPr lang="en-US" smtClean="0"/>
               <a:t>3</a:t>
             </a:fld>
@@ -1008,7 +1008,7 @@
     </p:spTree>
     <p:extLst>
       <p:ext uri="{BB962C8B-B14F-4D97-AF65-F5344CB8AC3E}">
-        <p14:creationId xmlns:p14="http://schemas.microsoft.com/office/powerpoint/2010/main" val="3107368802"/>
+        <p14:creationId xmlns:p14="http://schemas.microsoft.com/office/powerpoint/2010/main" val="2877252385"/>
       </p:ext>
     </p:extLst>
   </p:cSld>
@@ -1085,7 +1085,7 @@
           <a:bodyPr/>
           <a:lstStyle/>
           <a:p>
-            <a:fld id="{43CA2844-41C6-4F73-8CE2-E5A99E201805}" type="slidenum">
+            <a:fld id="{AA8A2905-1E39-4DE1-BA8A-2348BBA85102}" type="slidenum">
               <a:rPr lang="en-US" smtClean="0"/>
               <a:t>5</a:t>
             </a:fld>
@@ -1096,7 +1096,7 @@
     </p:spTree>
     <p:extLst>
       <p:ext uri="{BB962C8B-B14F-4D97-AF65-F5344CB8AC3E}">
-        <p14:creationId xmlns:p14="http://schemas.microsoft.com/office/powerpoint/2010/main" val="1954555902"/>
+        <p14:creationId xmlns:p14="http://schemas.microsoft.com/office/powerpoint/2010/main" val="623959211"/>
       </p:ext>
     </p:extLst>
   </p:cSld>
@@ -1173,7 +1173,7 @@
           <a:bodyPr/>
           <a:lstStyle/>
           <a:p>
-            <a:fld id="{43CA2844-41C6-4F73-8CE2-E5A99E201805}" type="slidenum">
+            <a:fld id="{AA8A2905-1E39-4DE1-BA8A-2348BBA85102}" type="slidenum">
               <a:rPr lang="en-US" smtClean="0"/>
               <a:t>6</a:t>
             </a:fld>
@@ -1184,7 +1184,7 @@
     </p:spTree>
     <p:extLst>
       <p:ext uri="{BB962C8B-B14F-4D97-AF65-F5344CB8AC3E}">
-        <p14:creationId xmlns:p14="http://schemas.microsoft.com/office/powerpoint/2010/main" val="133305108"/>
+        <p14:creationId xmlns:p14="http://schemas.microsoft.com/office/powerpoint/2010/main" val="2879855196"/>
       </p:ext>
     </p:extLst>
   </p:cSld>
@@ -1261,7 +1261,7 @@
           <a:bodyPr/>
           <a:lstStyle/>
           <a:p>
-            <a:fld id="{43CA2844-41C6-4F73-8CE2-E5A99E201805}" type="slidenum">
+            <a:fld id="{AA8A2905-1E39-4DE1-BA8A-2348BBA85102}" type="slidenum">
               <a:rPr lang="en-US" smtClean="0"/>
               <a:t>12</a:t>
             </a:fld>
@@ -1272,7 +1272,7 @@
     </p:spTree>
     <p:extLst>
       <p:ext uri="{BB962C8B-B14F-4D97-AF65-F5344CB8AC3E}">
-        <p14:creationId xmlns:p14="http://schemas.microsoft.com/office/powerpoint/2010/main" val="4119968734"/>
+        <p14:creationId xmlns:p14="http://schemas.microsoft.com/office/powerpoint/2010/main" val="2620801702"/>
       </p:ext>
     </p:extLst>
   </p:cSld>
@@ -1349,7 +1349,7 @@
           <a:bodyPr/>
           <a:lstStyle/>
           <a:p>
-            <a:fld id="{43CA2844-41C6-4F73-8CE2-E5A99E201805}" type="slidenum">
+            <a:fld id="{AA8A2905-1E39-4DE1-BA8A-2348BBA85102}" type="slidenum">
               <a:rPr lang="en-US" smtClean="0"/>
               <a:t>13</a:t>
             </a:fld>
@@ -1360,7 +1360,7 @@
     </p:spTree>
     <p:extLst>
       <p:ext uri="{BB962C8B-B14F-4D97-AF65-F5344CB8AC3E}">
-        <p14:creationId xmlns:p14="http://schemas.microsoft.com/office/powerpoint/2010/main" val="3342649103"/>
+        <p14:creationId xmlns:p14="http://schemas.microsoft.com/office/powerpoint/2010/main" val="3376431027"/>
       </p:ext>
     </p:extLst>
   </p:cSld>
@@ -1437,7 +1437,7 @@
           <a:bodyPr/>
           <a:lstStyle/>
           <a:p>
-            <a:fld id="{43CA2844-41C6-4F73-8CE2-E5A99E201805}" type="slidenum">
+            <a:fld id="{AA8A2905-1E39-4DE1-BA8A-2348BBA85102}" type="slidenum">
               <a:rPr lang="en-US" smtClean="0"/>
               <a:t>21</a:t>
             </a:fld>
@@ -1448,7 +1448,7 @@
     </p:spTree>
     <p:extLst>
       <p:ext uri="{BB962C8B-B14F-4D97-AF65-F5344CB8AC3E}">
-        <p14:creationId xmlns:p14="http://schemas.microsoft.com/office/powerpoint/2010/main" val="3283879144"/>
+        <p14:creationId xmlns:p14="http://schemas.microsoft.com/office/powerpoint/2010/main" val="3210951474"/>
       </p:ext>
     </p:extLst>
   </p:cSld>
@@ -1525,7 +1525,7 @@
           <a:bodyPr/>
           <a:lstStyle/>
           <a:p>
-            <a:fld id="{43CA2844-41C6-4F73-8CE2-E5A99E201805}" type="slidenum">
+            <a:fld id="{AA8A2905-1E39-4DE1-BA8A-2348BBA85102}" type="slidenum">
               <a:rPr lang="en-US" smtClean="0"/>
               <a:t>25</a:t>
             </a:fld>
@@ -1536,7 +1536,7 @@
     </p:spTree>
     <p:extLst>
       <p:ext uri="{BB962C8B-B14F-4D97-AF65-F5344CB8AC3E}">
-        <p14:creationId xmlns:p14="http://schemas.microsoft.com/office/powerpoint/2010/main" val="1180152249"/>
+        <p14:creationId xmlns:p14="http://schemas.microsoft.com/office/powerpoint/2010/main" val="1444014313"/>
       </p:ext>
     </p:extLst>
   </p:cSld>
@@ -1675,9 +1675,9 @@
           <a:bodyPr/>
           <a:lstStyle/>
           <a:p>
-            <a:fld id="{A1763678-8A38-4F5E-BAD5-561E39243491}" type="datetimeFigureOut">
+            <a:fld id="{09B2BC7F-7606-4572-8CF1-566ADCCFF939}" type="datetimeFigureOut">
               <a:rPr lang="en-US" smtClean="0"/>
-              <a:t>10/27/2026</a:t>
+              <a:t>10/30/2026</a:t>
             </a:fld>
             <a:endParaRPr lang="en-US"/>
           </a:p>
@@ -1717,7 +1717,7 @@
           <a:bodyPr/>
           <a:lstStyle/>
           <a:p>
-            <a:fld id="{CA70444B-4304-44DF-89D1-1795E5C3ECDC}" type="slidenum">
+            <a:fld id="{10788905-D1ED-47EB-8A00-A370EB16731F}" type="slidenum">
               <a:rPr lang="en-US" smtClean="0"/>
               <a:t>‹N°›</a:t>
             </a:fld>
@@ -1728,7 +1728,7 @@
     </p:spTree>
     <p:extLst>
       <p:ext uri="{BB962C8B-B14F-4D97-AF65-F5344CB8AC3E}">
-        <p14:creationId xmlns:p14="http://schemas.microsoft.com/office/powerpoint/2010/main" val="4123374707"/>
+        <p14:creationId xmlns:p14="http://schemas.microsoft.com/office/powerpoint/2010/main" val="284368549"/>
       </p:ext>
     </p:extLst>
   </p:cSld>
@@ -1845,9 +1845,9 @@
           <a:bodyPr/>
           <a:lstStyle/>
           <a:p>
-            <a:fld id="{A1763678-8A38-4F5E-BAD5-561E39243491}" type="datetimeFigureOut">
+            <a:fld id="{09B2BC7F-7606-4572-8CF1-566ADCCFF939}" type="datetimeFigureOut">
               <a:rPr lang="en-US" smtClean="0"/>
-              <a:t>10/27/2026</a:t>
+              <a:t>10/30/2026</a:t>
             </a:fld>
             <a:endParaRPr lang="en-US"/>
           </a:p>
@@ -1887,7 +1887,7 @@
           <a:bodyPr/>
           <a:lstStyle/>
           <a:p>
-            <a:fld id="{CA70444B-4304-44DF-89D1-1795E5C3ECDC}" type="slidenum">
+            <a:fld id="{10788905-D1ED-47EB-8A00-A370EB16731F}" type="slidenum">
               <a:rPr lang="en-US" smtClean="0"/>
               <a:t>‹N°›</a:t>
             </a:fld>
@@ -1898,7 +1898,7 @@
     </p:spTree>
     <p:extLst>
       <p:ext uri="{BB962C8B-B14F-4D97-AF65-F5344CB8AC3E}">
-        <p14:creationId xmlns:p14="http://schemas.microsoft.com/office/powerpoint/2010/main" val="4274534538"/>
+        <p14:creationId xmlns:p14="http://schemas.microsoft.com/office/powerpoint/2010/main" val="1693816571"/>
       </p:ext>
     </p:extLst>
   </p:cSld>
@@ -2025,9 +2025,9 @@
           <a:bodyPr/>
           <a:lstStyle/>
           <a:p>
-            <a:fld id="{A1763678-8A38-4F5E-BAD5-561E39243491}" type="datetimeFigureOut">
+            <a:fld id="{09B2BC7F-7606-4572-8CF1-566ADCCFF939}" type="datetimeFigureOut">
               <a:rPr lang="en-US" smtClean="0"/>
-              <a:t>10/27/2026</a:t>
+              <a:t>10/30/2026</a:t>
             </a:fld>
             <a:endParaRPr lang="en-US"/>
           </a:p>
@@ -2067,7 +2067,7 @@
           <a:bodyPr/>
           <a:lstStyle/>
           <a:p>
-            <a:fld id="{CA70444B-4304-44DF-89D1-1795E5C3ECDC}" type="slidenum">
+            <a:fld id="{10788905-D1ED-47EB-8A00-A370EB16731F}" type="slidenum">
               <a:rPr lang="en-US" smtClean="0"/>
               <a:t>‹N°›</a:t>
             </a:fld>
@@ -2078,7 +2078,7 @@
     </p:spTree>
     <p:extLst>
       <p:ext uri="{BB962C8B-B14F-4D97-AF65-F5344CB8AC3E}">
-        <p14:creationId xmlns:p14="http://schemas.microsoft.com/office/powerpoint/2010/main" val="4014496696"/>
+        <p14:creationId xmlns:p14="http://schemas.microsoft.com/office/powerpoint/2010/main" val="3103449374"/>
       </p:ext>
     </p:extLst>
   </p:cSld>
@@ -2195,9 +2195,9 @@
           <a:bodyPr/>
           <a:lstStyle/>
           <a:p>
-            <a:fld id="{A1763678-8A38-4F5E-BAD5-561E39243491}" type="datetimeFigureOut">
+            <a:fld id="{09B2BC7F-7606-4572-8CF1-566ADCCFF939}" type="datetimeFigureOut">
               <a:rPr lang="en-US" smtClean="0"/>
-              <a:t>10/27/2026</a:t>
+              <a:t>10/30/2026</a:t>
             </a:fld>
             <a:endParaRPr lang="en-US"/>
           </a:p>
@@ -2237,7 +2237,7 @@
           <a:bodyPr/>
           <a:lstStyle/>
           <a:p>
-            <a:fld id="{CA70444B-4304-44DF-89D1-1795E5C3ECDC}" type="slidenum">
+            <a:fld id="{10788905-D1ED-47EB-8A00-A370EB16731F}" type="slidenum">
               <a:rPr lang="en-US" smtClean="0"/>
               <a:t>‹N°›</a:t>
             </a:fld>
@@ -2248,7 +2248,7 @@
     </p:spTree>
     <p:extLst>
       <p:ext uri="{BB962C8B-B14F-4D97-AF65-F5344CB8AC3E}">
-        <p14:creationId xmlns:p14="http://schemas.microsoft.com/office/powerpoint/2010/main" val="2685767673"/>
+        <p14:creationId xmlns:p14="http://schemas.microsoft.com/office/powerpoint/2010/main" val="1759684624"/>
       </p:ext>
     </p:extLst>
   </p:cSld>
@@ -2441,9 +2441,9 @@
           <a:bodyPr/>
           <a:lstStyle/>
           <a:p>
-            <a:fld id="{A1763678-8A38-4F5E-BAD5-561E39243491}" type="datetimeFigureOut">
+            <a:fld id="{09B2BC7F-7606-4572-8CF1-566ADCCFF939}" type="datetimeFigureOut">
               <a:rPr lang="en-US" smtClean="0"/>
-              <a:t>10/27/2026</a:t>
+              <a:t>10/30/2026</a:t>
             </a:fld>
             <a:endParaRPr lang="en-US"/>
           </a:p>
@@ -2483,7 +2483,7 @@
           <a:bodyPr/>
           <a:lstStyle/>
           <a:p>
-            <a:fld id="{CA70444B-4304-44DF-89D1-1795E5C3ECDC}" type="slidenum">
+            <a:fld id="{10788905-D1ED-47EB-8A00-A370EB16731F}" type="slidenum">
               <a:rPr lang="en-US" smtClean="0"/>
               <a:t>‹N°›</a:t>
             </a:fld>
@@ -2494,7 +2494,7 @@
     </p:spTree>
     <p:extLst>
       <p:ext uri="{BB962C8B-B14F-4D97-AF65-F5344CB8AC3E}">
-        <p14:creationId xmlns:p14="http://schemas.microsoft.com/office/powerpoint/2010/main" val="252381462"/>
+        <p14:creationId xmlns:p14="http://schemas.microsoft.com/office/powerpoint/2010/main" val="3472537161"/>
       </p:ext>
     </p:extLst>
   </p:cSld>
@@ -2673,9 +2673,9 @@
           <a:bodyPr/>
           <a:lstStyle/>
           <a:p>
-            <a:fld id="{A1763678-8A38-4F5E-BAD5-561E39243491}" type="datetimeFigureOut">
+            <a:fld id="{09B2BC7F-7606-4572-8CF1-566ADCCFF939}" type="datetimeFigureOut">
               <a:rPr lang="en-US" smtClean="0"/>
-              <a:t>10/27/2026</a:t>
+              <a:t>10/30/2026</a:t>
             </a:fld>
             <a:endParaRPr lang="en-US"/>
           </a:p>
@@ -2715,7 +2715,7 @@
           <a:bodyPr/>
           <a:lstStyle/>
           <a:p>
-            <a:fld id="{CA70444B-4304-44DF-89D1-1795E5C3ECDC}" type="slidenum">
+            <a:fld id="{10788905-D1ED-47EB-8A00-A370EB16731F}" type="slidenum">
               <a:rPr lang="en-US" smtClean="0"/>
               <a:t>‹N°›</a:t>
             </a:fld>
@@ -2726,7 +2726,7 @@
     </p:spTree>
     <p:extLst>
       <p:ext uri="{BB962C8B-B14F-4D97-AF65-F5344CB8AC3E}">
-        <p14:creationId xmlns:p14="http://schemas.microsoft.com/office/powerpoint/2010/main" val="2427776104"/>
+        <p14:creationId xmlns:p14="http://schemas.microsoft.com/office/powerpoint/2010/main" val="2273761564"/>
       </p:ext>
     </p:extLst>
   </p:cSld>
@@ -3040,9 +3040,9 @@
           <a:bodyPr/>
           <a:lstStyle/>
           <a:p>
-            <a:fld id="{A1763678-8A38-4F5E-BAD5-561E39243491}" type="datetimeFigureOut">
+            <a:fld id="{09B2BC7F-7606-4572-8CF1-566ADCCFF939}" type="datetimeFigureOut">
               <a:rPr lang="en-US" smtClean="0"/>
-              <a:t>10/27/2026</a:t>
+              <a:t>10/30/2026</a:t>
             </a:fld>
             <a:endParaRPr lang="en-US"/>
           </a:p>
@@ -3082,7 +3082,7 @@
           <a:bodyPr/>
           <a:lstStyle/>
           <a:p>
-            <a:fld id="{CA70444B-4304-44DF-89D1-1795E5C3ECDC}" type="slidenum">
+            <a:fld id="{10788905-D1ED-47EB-8A00-A370EB16731F}" type="slidenum">
               <a:rPr lang="en-US" smtClean="0"/>
               <a:t>‹N°›</a:t>
             </a:fld>
@@ -3093,7 +3093,7 @@
     </p:spTree>
     <p:extLst>
       <p:ext uri="{BB962C8B-B14F-4D97-AF65-F5344CB8AC3E}">
-        <p14:creationId xmlns:p14="http://schemas.microsoft.com/office/powerpoint/2010/main" val="3797292461"/>
+        <p14:creationId xmlns:p14="http://schemas.microsoft.com/office/powerpoint/2010/main" val="3125897374"/>
       </p:ext>
     </p:extLst>
   </p:cSld>
@@ -3158,9 +3158,9 @@
           <a:bodyPr/>
           <a:lstStyle/>
           <a:p>
-            <a:fld id="{A1763678-8A38-4F5E-BAD5-561E39243491}" type="datetimeFigureOut">
+            <a:fld id="{09B2BC7F-7606-4572-8CF1-566ADCCFF939}" type="datetimeFigureOut">
               <a:rPr lang="en-US" smtClean="0"/>
-              <a:t>10/27/2026</a:t>
+              <a:t>10/30/2026</a:t>
             </a:fld>
             <a:endParaRPr lang="en-US"/>
           </a:p>
@@ -3200,7 +3200,7 @@
           <a:bodyPr/>
           <a:lstStyle/>
           <a:p>
-            <a:fld id="{CA70444B-4304-44DF-89D1-1795E5C3ECDC}" type="slidenum">
+            <a:fld id="{10788905-D1ED-47EB-8A00-A370EB16731F}" type="slidenum">
               <a:rPr lang="en-US" smtClean="0"/>
               <a:t>‹N°›</a:t>
             </a:fld>
@@ -3211,7 +3211,7 @@
     </p:spTree>
     <p:extLst>
       <p:ext uri="{BB962C8B-B14F-4D97-AF65-F5344CB8AC3E}">
-        <p14:creationId xmlns:p14="http://schemas.microsoft.com/office/powerpoint/2010/main" val="1253988376"/>
+        <p14:creationId xmlns:p14="http://schemas.microsoft.com/office/powerpoint/2010/main" val="928397760"/>
       </p:ext>
     </p:extLst>
   </p:cSld>
@@ -3253,9 +3253,9 @@
           <a:bodyPr/>
           <a:lstStyle/>
           <a:p>
-            <a:fld id="{A1763678-8A38-4F5E-BAD5-561E39243491}" type="datetimeFigureOut">
+            <a:fld id="{09B2BC7F-7606-4572-8CF1-566ADCCFF939}" type="datetimeFigureOut">
               <a:rPr lang="en-US" smtClean="0"/>
-              <a:t>10/27/2026</a:t>
+              <a:t>10/30/2026</a:t>
             </a:fld>
             <a:endParaRPr lang="en-US"/>
           </a:p>
@@ -3295,7 +3295,7 @@
           <a:bodyPr/>
           <a:lstStyle/>
           <a:p>
-            <a:fld id="{CA70444B-4304-44DF-89D1-1795E5C3ECDC}" type="slidenum">
+            <a:fld id="{10788905-D1ED-47EB-8A00-A370EB16731F}" type="slidenum">
               <a:rPr lang="en-US" smtClean="0"/>
               <a:t>‹N°›</a:t>
             </a:fld>
@@ -3306,7 +3306,7 @@
     </p:spTree>
     <p:extLst>
       <p:ext uri="{BB962C8B-B14F-4D97-AF65-F5344CB8AC3E}">
-        <p14:creationId xmlns:p14="http://schemas.microsoft.com/office/powerpoint/2010/main" val="1770173656"/>
+        <p14:creationId xmlns:p14="http://schemas.microsoft.com/office/powerpoint/2010/main" val="2321747265"/>
       </p:ext>
     </p:extLst>
   </p:cSld>
@@ -3530,9 +3530,9 @@
           <a:bodyPr/>
           <a:lstStyle/>
           <a:p>
-            <a:fld id="{A1763678-8A38-4F5E-BAD5-561E39243491}" type="datetimeFigureOut">
+            <a:fld id="{09B2BC7F-7606-4572-8CF1-566ADCCFF939}" type="datetimeFigureOut">
               <a:rPr lang="en-US" smtClean="0"/>
-              <a:t>10/27/2026</a:t>
+              <a:t>10/30/2026</a:t>
             </a:fld>
             <a:endParaRPr lang="en-US"/>
           </a:p>
@@ -3572,7 +3572,7 @@
           <a:bodyPr/>
           <a:lstStyle/>
           <a:p>
-            <a:fld id="{CA70444B-4304-44DF-89D1-1795E5C3ECDC}" type="slidenum">
+            <a:fld id="{10788905-D1ED-47EB-8A00-A370EB16731F}" type="slidenum">
               <a:rPr lang="en-US" smtClean="0"/>
               <a:t>‹N°›</a:t>
             </a:fld>
@@ -3583,7 +3583,7 @@
     </p:spTree>
     <p:extLst>
       <p:ext uri="{BB962C8B-B14F-4D97-AF65-F5344CB8AC3E}">
-        <p14:creationId xmlns:p14="http://schemas.microsoft.com/office/powerpoint/2010/main" val="794841822"/>
+        <p14:creationId xmlns:p14="http://schemas.microsoft.com/office/powerpoint/2010/main" val="4199941812"/>
       </p:ext>
     </p:extLst>
   </p:cSld>
@@ -3783,9 +3783,9 @@
           <a:bodyPr/>
           <a:lstStyle/>
           <a:p>
-            <a:fld id="{A1763678-8A38-4F5E-BAD5-561E39243491}" type="datetimeFigureOut">
+            <a:fld id="{09B2BC7F-7606-4572-8CF1-566ADCCFF939}" type="datetimeFigureOut">
               <a:rPr lang="en-US" smtClean="0"/>
-              <a:t>10/27/2026</a:t>
+              <a:t>10/30/2026</a:t>
             </a:fld>
             <a:endParaRPr lang="en-US"/>
           </a:p>
@@ -3825,7 +3825,7 @@
           <a:bodyPr/>
           <a:lstStyle/>
           <a:p>
-            <a:fld id="{CA70444B-4304-44DF-89D1-1795E5C3ECDC}" type="slidenum">
+            <a:fld id="{10788905-D1ED-47EB-8A00-A370EB16731F}" type="slidenum">
               <a:rPr lang="en-US" smtClean="0"/>
               <a:t>‹N°›</a:t>
             </a:fld>
@@ -3836,7 +3836,7 @@
     </p:spTree>
     <p:extLst>
       <p:ext uri="{BB962C8B-B14F-4D97-AF65-F5344CB8AC3E}">
-        <p14:creationId xmlns:p14="http://schemas.microsoft.com/office/powerpoint/2010/main" val="1923921519"/>
+        <p14:creationId xmlns:p14="http://schemas.microsoft.com/office/powerpoint/2010/main" val="4180948047"/>
       </p:ext>
     </p:extLst>
   </p:cSld>
@@ -3996,9 +3996,9 @@
             </a:lvl1pPr>
           </a:lstStyle>
           <a:p>
-            <a:fld id="{A1763678-8A38-4F5E-BAD5-561E39243491}" type="datetimeFigureOut">
+            <a:fld id="{09B2BC7F-7606-4572-8CF1-566ADCCFF939}" type="datetimeFigureOut">
               <a:rPr lang="en-US" smtClean="0"/>
-              <a:t>10/27/2026</a:t>
+              <a:t>10/30/2026</a:t>
             </a:fld>
             <a:endParaRPr lang="en-US"/>
           </a:p>
@@ -4074,7 +4074,7 @@
             </a:lvl1pPr>
           </a:lstStyle>
           <a:p>
-            <a:fld id="{CA70444B-4304-44DF-89D1-1795E5C3ECDC}" type="slidenum">
+            <a:fld id="{10788905-D1ED-47EB-8A00-A370EB16731F}" type="slidenum">
               <a:rPr lang="en-US" smtClean="0"/>
               <a:t>‹N°›</a:t>
             </a:fld>
@@ -4085,7 +4085,7 @@
     </p:spTree>
     <p:extLst>
       <p:ext uri="{BB962C8B-B14F-4D97-AF65-F5344CB8AC3E}">
-        <p14:creationId xmlns:p14="http://schemas.microsoft.com/office/powerpoint/2010/main" val="3360466007"/>
+        <p14:creationId xmlns:p14="http://schemas.microsoft.com/office/powerpoint/2010/main" val="2788477093"/>
       </p:ext>
     </p:extLst>
   </p:cSld>
@@ -4761,7 +4761,7 @@
                 </a:solidFill>
                 <a:latin typeface="Segoe UI" panose="020B0502040204020203" pitchFamily="34" charset="0"/>
               </a:rPr>
-              <a:t>Etienne FOYANG · DPI · Octobre 2026</a:t>
+              <a:t>Etienne FOYANG · DPI (Data Process et Innovation) · Octobre 2026</a:t>
             </a:r>
             <a:endParaRPr lang="en-US" sz="1300">
               <a:solidFill>
@@ -4775,20 +4775,13 @@
     </p:spTree>
     <p:extLst>
       <p:ext uri="{BB962C8B-B14F-4D97-AF65-F5344CB8AC3E}">
-        <p14:creationId xmlns:p14="http://schemas.microsoft.com/office/powerpoint/2010/main" val="1458662241"/>
+        <p14:creationId xmlns:p14="http://schemas.microsoft.com/office/powerpoint/2010/main" val="3211436177"/>
       </p:ext>
     </p:extLst>
   </p:cSld>
   <p:clrMapOvr>
     <a:masterClrMapping/>
   </p:clrMapOvr>
-  <p:timing>
-    <p:tnLst>
-      <p:par>
-        <p:cTn id="1" dur="indefinite" restart="never" nodeType="tmRoot"/>
-      </p:par>
-    </p:tnLst>
-  </p:timing>
 </p:sld>
 </file>
 
@@ -6273,20 +6266,13 @@
     </p:spTree>
     <p:extLst>
       <p:ext uri="{BB962C8B-B14F-4D97-AF65-F5344CB8AC3E}">
-        <p14:creationId xmlns:p14="http://schemas.microsoft.com/office/powerpoint/2010/main" val="1381764907"/>
+        <p14:creationId xmlns:p14="http://schemas.microsoft.com/office/powerpoint/2010/main" val="1300612105"/>
       </p:ext>
     </p:extLst>
   </p:cSld>
   <p:clrMapOvr>
     <a:masterClrMapping/>
   </p:clrMapOvr>
-  <p:timing>
-    <p:tnLst>
-      <p:par>
-        <p:cTn id="1" dur="indefinite" restart="never" nodeType="tmRoot"/>
-      </p:par>
-    </p:tnLst>
-  </p:timing>
 </p:sld>
 </file>
 
@@ -6991,7 +6977,7 @@
                 </a:solidFill>
                 <a:latin typeface="Consolas" panose="020B0609020204030204" pitchFamily="49" charset="0"/>
               </a:rPr>
-              <a:t>                  name="Jira Clarification Loop" plugins-version="2"&gt;</a:t>
+              <a:t>                  name="Demandes d'informations supplémentaires" plugins-version="2"&gt;</a:t>
             </a:r>
           </a:p>
           <a:p>
@@ -7024,7 +7010,7 @@
                 </a:solidFill>
                 <a:latin typeface="Consolas" panose="020B0609020204030204" pitchFamily="49" charset="0"/>
               </a:rPr>
-              <a:t>    &lt;vendor name="Ma Banque - DPI" url="https://www.mabanque.fr"/&gt;</a:t>
+              <a:t>    &lt;vendor name="DPI - Data Process et Innovation" url="https://www.mabanque.fr"/&gt;</a:t>
             </a:r>
           </a:p>
           <a:p>
@@ -7087,7 +7073,7 @@
                 </a:solidFill>
                 <a:latin typeface="Consolas" panose="020B0609020204030204" pitchFamily="49" charset="0"/>
               </a:rPr>
-              <a:t>  &lt;web-resource key="clarification-resources"&gt;</a:t>
+              <a:t>  &lt;web-resource key="clarification-resources-v4"&gt;</a:t>
             </a:r>
           </a:p>
           <a:p>
@@ -7161,7 +7147,7 @@
                 </a:solidFill>
                 <a:latin typeface="Consolas" panose="020B0609020204030204" pitchFamily="49" charset="0"/>
               </a:rPr>
-              <a:t>  &lt;web-panel key="clarification-panel" location="atl.jira.view.issue.right.context"&gt;</a:t>
+              <a:t>  &lt;web-panel key="panneau-demande-infos-sup" location="atl.jira.view.issue.right.context"&gt;</a:t>
             </a:r>
           </a:p>
           <a:p>
@@ -7296,7 +7282,7 @@
                 </a:solidFill>
                 <a:latin typeface="Segoe UI" panose="020B0502040204020203" pitchFamily="34" charset="0"/>
               </a:rPr>
-              <a:t> : version, éditeur, compatibilité Data Center</a:t>
+              <a:t> : version, éditeur (DPI), compatibilité Data Center</a:t>
             </a:r>
           </a:p>
           <a:p>
@@ -7349,7 +7335,7 @@
                 </a:solidFill>
                 <a:latin typeface="Segoe UI" panose="020B0502040204020203" pitchFamily="34" charset="0"/>
               </a:rPr>
-              <a:t>web-panel</a:t>
+              <a:t>web-panel (panneau-demande-infos-sup)</a:t>
             </a:r>
             <a:r>
               <a:rPr lang="fr-FR" sz="1250" smtClean="0">
@@ -7358,7 +7344,7 @@
                 </a:solidFill>
                 <a:latin typeface="Segoe UI" panose="020B0502040204020203" pitchFamily="34" charset="0"/>
               </a:rPr>
-              <a:t> : affiche le panneau « Demandes de précision » dans la colonne de droite du ticket</a:t>
+              <a:t> : affiche le panneau « Demandes d'informations supplémentaires » à droite du ticket</a:t>
             </a:r>
           </a:p>
           <a:p>
@@ -7403,20 +7389,13 @@
     </p:spTree>
     <p:extLst>
       <p:ext uri="{BB962C8B-B14F-4D97-AF65-F5344CB8AC3E}">
-        <p14:creationId xmlns:p14="http://schemas.microsoft.com/office/powerpoint/2010/main" val="1165847166"/>
+        <p14:creationId xmlns:p14="http://schemas.microsoft.com/office/powerpoint/2010/main" val="887865908"/>
       </p:ext>
     </p:extLst>
   </p:cSld>
   <p:clrMapOvr>
     <a:masterClrMapping/>
   </p:clrMapOvr>
-  <p:timing>
-    <p:tnLst>
-      <p:par>
-        <p:cTn id="1" dur="indefinite" restart="never" nodeType="tmRoot"/>
-      </p:par>
-    </p:tnLst>
-  </p:timing>
 </p:sld>
 </file>
 
@@ -7801,14 +7780,14 @@
           <p:nvPr>
             <p:extLst>
               <p:ext uri="{D42A27DB-BD31-4B8C-83A1-F6EECF244321}">
-                <p14:modId xmlns:p14="http://schemas.microsoft.com/office/powerpoint/2010/main" val="1632841350"/>
+                <p14:modId xmlns:p14="http://schemas.microsoft.com/office/powerpoint/2010/main" val="3203787521"/>
               </p:ext>
             </p:extLst>
           </p:nvPr>
         </p:nvGraphicFramePr>
         <p:xfrm>
           <a:off x="508000" y="1219200"/>
-          <a:ext cx="11176000" cy="3408680"/>
+          <a:ext cx="11176000" cy="2794000"/>
         </p:xfrm>
         <a:graphic>
           <a:graphicData uri="http://schemas.openxmlformats.org/drawingml/2006/table">
@@ -7820,21 +7799,21 @@
                 <a:gridCol w="1905000">
                   <a:extLst>
                     <a:ext uri="{9D8B030D-6E8A-4147-A177-3AD203B41FA5}">
-                      <a16:colId xmlns:a16="http://schemas.microsoft.com/office/drawing/2014/main" val="2739585738"/>
+                      <a16:colId xmlns:a16="http://schemas.microsoft.com/office/drawing/2014/main" val="2659489578"/>
                     </a:ext>
                   </a:extLst>
                 </a:gridCol>
                 <a:gridCol w="3937000">
                   <a:extLst>
                     <a:ext uri="{9D8B030D-6E8A-4147-A177-3AD203B41FA5}">
-                      <a16:colId xmlns:a16="http://schemas.microsoft.com/office/drawing/2014/main" val="857420243"/>
+                      <a16:colId xmlns:a16="http://schemas.microsoft.com/office/drawing/2014/main" val="3537918108"/>
                     </a:ext>
                   </a:extLst>
                 </a:gridCol>
                 <a:gridCol w="5334000">
                   <a:extLst>
                     <a:ext uri="{9D8B030D-6E8A-4147-A177-3AD203B41FA5}">
-                      <a16:colId xmlns:a16="http://schemas.microsoft.com/office/drawing/2014/main" val="1035423780"/>
+                      <a16:colId xmlns:a16="http://schemas.microsoft.com/office/drawing/2014/main" val="1382463522"/>
                     </a:ext>
                   </a:extLst>
                 </a:gridCol>
@@ -7926,7 +7905,7 @@
                 </a:tc>
                 <a:extLst>
                   <a:ext uri="{0D108BD9-81ED-4DB2-BD59-A6C34878D82A}">
-                    <a16:rowId xmlns:a16="http://schemas.microsoft.com/office/drawing/2014/main" val="1789616582"/>
+                    <a16:rowId xmlns:a16="http://schemas.microsoft.com/office/drawing/2014/main" val="440056162"/>
                   </a:ext>
                 </a:extLst>
               </a:tr>
@@ -8017,7 +7996,7 @@
                 </a:tc>
                 <a:extLst>
                   <a:ext uri="{0D108BD9-81ED-4DB2-BD59-A6C34878D82A}">
-                    <a16:rowId xmlns:a16="http://schemas.microsoft.com/office/drawing/2014/main" val="3549579589"/>
+                    <a16:rowId xmlns:a16="http://schemas.microsoft.com/office/drawing/2014/main" val="2107854080"/>
                   </a:ext>
                 </a:extLst>
               </a:tr>
@@ -8108,7 +8087,7 @@
                 </a:tc>
                 <a:extLst>
                   <a:ext uri="{0D108BD9-81ED-4DB2-BD59-A6C34878D82A}">
-                    <a16:rowId xmlns:a16="http://schemas.microsoft.com/office/drawing/2014/main" val="1693092693"/>
+                    <a16:rowId xmlns:a16="http://schemas.microsoft.com/office/drawing/2014/main" val="741529247"/>
                   </a:ext>
                 </a:extLst>
               </a:tr>
@@ -8199,7 +8178,7 @@
                 </a:tc>
                 <a:extLst>
                   <a:ext uri="{0D108BD9-81ED-4DB2-BD59-A6C34878D82A}">
-                    <a16:rowId xmlns:a16="http://schemas.microsoft.com/office/drawing/2014/main" val="3870417733"/>
+                    <a16:rowId xmlns:a16="http://schemas.microsoft.com/office/drawing/2014/main" val="2206152542"/>
                   </a:ext>
                 </a:extLst>
               </a:tr>
@@ -8290,7 +8269,7 @@
                 </a:tc>
                 <a:extLst>
                   <a:ext uri="{0D108BD9-81ED-4DB2-BD59-A6C34878D82A}">
-                    <a16:rowId xmlns:a16="http://schemas.microsoft.com/office/drawing/2014/main" val="4160241738"/>
+                    <a16:rowId xmlns:a16="http://schemas.microsoft.com/office/drawing/2014/main" val="3583946772"/>
                   </a:ext>
                 </a:extLst>
               </a:tr>
@@ -8381,7 +8360,7 @@
                 </a:tc>
                 <a:extLst>
                   <a:ext uri="{0D108BD9-81ED-4DB2-BD59-A6C34878D82A}">
-                    <a16:rowId xmlns:a16="http://schemas.microsoft.com/office/drawing/2014/main" val="3412124949"/>
+                    <a16:rowId xmlns:a16="http://schemas.microsoft.com/office/drawing/2014/main" val="9100116"/>
                   </a:ext>
                 </a:extLst>
               </a:tr>
@@ -8472,7 +8451,7 @@
                 </a:tc>
                 <a:extLst>
                   <a:ext uri="{0D108BD9-81ED-4DB2-BD59-A6C34878D82A}">
-                    <a16:rowId xmlns:a16="http://schemas.microsoft.com/office/drawing/2014/main" val="3899823398"/>
+                    <a16:rowId xmlns:a16="http://schemas.microsoft.com/office/drawing/2014/main" val="952654277"/>
                   </a:ext>
                 </a:extLst>
               </a:tr>
@@ -8563,7 +8542,7 @@
                 </a:tc>
                 <a:extLst>
                   <a:ext uri="{0D108BD9-81ED-4DB2-BD59-A6C34878D82A}">
-                    <a16:rowId xmlns:a16="http://schemas.microsoft.com/office/drawing/2014/main" val="495967786"/>
+                    <a16:rowId xmlns:a16="http://schemas.microsoft.com/office/drawing/2014/main" val="3446772016"/>
                   </a:ext>
                 </a:extLst>
               </a:tr>
@@ -8654,7 +8633,7 @@
                 </a:tc>
                 <a:extLst>
                   <a:ext uri="{0D108BD9-81ED-4DB2-BD59-A6C34878D82A}">
-                    <a16:rowId xmlns:a16="http://schemas.microsoft.com/office/drawing/2014/main" val="1162510426"/>
+                    <a16:rowId xmlns:a16="http://schemas.microsoft.com/office/drawing/2014/main" val="2401764381"/>
                   </a:ext>
                 </a:extLst>
               </a:tr>
@@ -8745,7 +8724,7 @@
                 </a:tc>
                 <a:extLst>
                   <a:ext uri="{0D108BD9-81ED-4DB2-BD59-A6C34878D82A}">
-                    <a16:rowId xmlns:a16="http://schemas.microsoft.com/office/drawing/2014/main" val="3206304353"/>
+                    <a16:rowId xmlns:a16="http://schemas.microsoft.com/office/drawing/2014/main" val="43472935"/>
                   </a:ext>
                 </a:extLst>
               </a:tr>
@@ -8836,7 +8815,7 @@
                 </a:tc>
                 <a:extLst>
                   <a:ext uri="{0D108BD9-81ED-4DB2-BD59-A6C34878D82A}">
-                    <a16:rowId xmlns:a16="http://schemas.microsoft.com/office/drawing/2014/main" val="3972476859"/>
+                    <a16:rowId xmlns:a16="http://schemas.microsoft.com/office/drawing/2014/main" val="1221652287"/>
                   </a:ext>
                 </a:extLst>
               </a:tr>
@@ -8847,20 +8826,13 @@
     </p:spTree>
     <p:extLst>
       <p:ext uri="{BB962C8B-B14F-4D97-AF65-F5344CB8AC3E}">
-        <p14:creationId xmlns:p14="http://schemas.microsoft.com/office/powerpoint/2010/main" val="1180552978"/>
+        <p14:creationId xmlns:p14="http://schemas.microsoft.com/office/powerpoint/2010/main" val="3078622671"/>
       </p:ext>
     </p:extLst>
   </p:cSld>
   <p:clrMapOvr>
     <a:masterClrMapping/>
   </p:clrMapOvr>
-  <p:timing>
-    <p:tnLst>
-      <p:par>
-        <p:cTn id="1" dur="indefinite" restart="never" nodeType="tmRoot"/>
-      </p:par>
-    </p:tnLst>
-  </p:timing>
 </p:sld>
 </file>
 
@@ -10008,20 +9980,13 @@
     </p:spTree>
     <p:extLst>
       <p:ext uri="{BB962C8B-B14F-4D97-AF65-F5344CB8AC3E}">
-        <p14:creationId xmlns:p14="http://schemas.microsoft.com/office/powerpoint/2010/main" val="2009683631"/>
+        <p14:creationId xmlns:p14="http://schemas.microsoft.com/office/powerpoint/2010/main" val="3868485551"/>
       </p:ext>
     </p:extLst>
   </p:cSld>
   <p:clrMapOvr>
     <a:masterClrMapping/>
   </p:clrMapOvr>
-  <p:timing>
-    <p:tnLst>
-      <p:par>
-        <p:cTn id="1" dur="indefinite" restart="never" nodeType="tmRoot"/>
-      </p:par>
-    </p:tnLst>
-  </p:timing>
 </p:sld>
 </file>
 
@@ -11288,7 +11253,7 @@
                 </a:solidFill>
                 <a:latin typeface="Consolas" panose="020B0609020204030204" pitchFamily="49" charset="0"/>
               </a:rPr>
-              <a:t>    &lt;description&gt;API REST pour les demandes de précision&lt;/description&gt;</a:t>
+              <a:t>    &lt;description&gt;API REST pour les demandes d'informations supplémentaires&lt;/description&gt;</a:t>
             </a:r>
           </a:p>
           <a:p>
@@ -11585,20 +11550,13 @@
     </p:spTree>
     <p:extLst>
       <p:ext uri="{BB962C8B-B14F-4D97-AF65-F5344CB8AC3E}">
-        <p14:creationId xmlns:p14="http://schemas.microsoft.com/office/powerpoint/2010/main" val="4128626221"/>
+        <p14:creationId xmlns:p14="http://schemas.microsoft.com/office/powerpoint/2010/main" val="3847750808"/>
       </p:ext>
     </p:extLst>
   </p:cSld>
   <p:clrMapOvr>
     <a:masterClrMapping/>
   </p:clrMapOvr>
-  <p:timing>
-    <p:tnLst>
-      <p:par>
-        <p:cTn id="1" dur="indefinite" restart="never" nodeType="tmRoot"/>
-      </p:par>
-    </p:tnLst>
-  </p:timing>
 </p:sld>
 </file>
 
@@ -12246,7 +12204,7 @@
                 </a:solidFill>
                 <a:latin typeface="Segoe UI" panose="020B0502040204020203" pitchFamily="34" charset="0"/>
               </a:rPr>
-              <a:t>Panneau latéral &amp; modale AUI « Demander une précision »</a:t>
+              <a:t>Panneau latéral &amp; modale AUI « Demande d'informations supplémentaires »</a:t>
             </a:r>
             <a:endParaRPr lang="en-US" sz="1300" b="1">
               <a:solidFill>
@@ -12641,53 +12599,16 @@
           </a:p>
         </p:txBody>
       </p:sp>
-      <p:pic>
-        <p:nvPicPr>
-          <p:cNvPr id="17" name="Image 16"/>
-          <p:cNvPicPr>
-            <a:picLocks noChangeAspect="1"/>
-          </p:cNvPicPr>
-          <p:nvPr/>
-        </p:nvPicPr>
-        <p:blipFill>
-          <a:blip r:embed="rId2">
-            <a:extLst>
-              <a:ext uri="{28A0092B-C50C-407E-A947-70E740481C1C}">
-                <a14:useLocalDpi xmlns:a14="http://schemas.microsoft.com/office/drawing/2010/main" val="0"/>
-              </a:ext>
-            </a:extLst>
-          </a:blip>
-          <a:stretch>
-            <a:fillRect/>
-          </a:stretch>
-        </p:blipFill>
-        <p:spPr>
-          <a:xfrm>
-            <a:off x="6743700" y="1270000"/>
-            <a:ext cx="4927600" cy="3013847"/>
-          </a:xfrm>
-          <a:prstGeom prst="rect">
-            <a:avLst/>
-          </a:prstGeom>
-        </p:spPr>
-      </p:pic>
     </p:spTree>
     <p:extLst>
       <p:ext uri="{BB962C8B-B14F-4D97-AF65-F5344CB8AC3E}">
-        <p14:creationId xmlns:p14="http://schemas.microsoft.com/office/powerpoint/2010/main" val="1305965112"/>
+        <p14:creationId xmlns:p14="http://schemas.microsoft.com/office/powerpoint/2010/main" val="1794459085"/>
       </p:ext>
     </p:extLst>
   </p:cSld>
   <p:clrMapOvr>
     <a:masterClrMapping/>
   </p:clrMapOvr>
-  <p:timing>
-    <p:tnLst>
-      <p:par>
-        <p:cTn id="1" dur="indefinite" restart="never" nodeType="tmRoot"/>
-      </p:par>
-    </p:tnLst>
-  </p:timing>
 </p:sld>
 </file>
 
@@ -14198,13 +14119,13 @@
           <a:lstStyle/>
           <a:p>
             <a:r>
-              <a:rPr lang="fr-FR" sz="1250" smtClean="0">
+              <a:rPr lang="en-US" sz="1250" smtClean="0">
                 <a:solidFill>
                   <a:srgbClr val="212121"/>
                 </a:solidFill>
                 <a:latin typeface="Segoe UI" panose="020B0502040204020203" pitchFamily="34" charset="0"/>
               </a:rPr>
-              <a:t>atlas-run démarre Jira une seule fois. Ensuite, QuickReload réinstalle automatiquement le plugin à chaque atlas-package, sans redémarrer Jira : quelques secondes entre une modification et son test.</a:t>
+              <a:t>atlas-run démarre Jira une seule fois. Ensuite, QuickReload réinstalle automatiquement le plugin dès que le .jar est recompilé (ex. atlas-package -DskipTests ou mvn package -DskipTests), sans redémarrer Jira.</a:t>
             </a:r>
             <a:endParaRPr lang="en-US" sz="1250">
               <a:solidFill>
@@ -14462,20 +14383,13 @@
     </p:spTree>
     <p:extLst>
       <p:ext uri="{BB962C8B-B14F-4D97-AF65-F5344CB8AC3E}">
-        <p14:creationId xmlns:p14="http://schemas.microsoft.com/office/powerpoint/2010/main" val="247764508"/>
+        <p14:creationId xmlns:p14="http://schemas.microsoft.com/office/powerpoint/2010/main" val="3565975345"/>
       </p:ext>
     </p:extLst>
   </p:cSld>
   <p:clrMapOvr>
     <a:masterClrMapping/>
   </p:clrMapOvr>
-  <p:timing>
-    <p:tnLst>
-      <p:par>
-        <p:cTn id="1" dur="indefinite" restart="never" nodeType="tmRoot"/>
-      </p:par>
-    </p:tnLst>
-  </p:timing>
 </p:sld>
 </file>
 
@@ -14860,14 +14774,14 @@
           <p:nvPr>
             <p:extLst>
               <p:ext uri="{D42A27DB-BD31-4B8C-83A1-F6EECF244321}">
-                <p14:modId xmlns:p14="http://schemas.microsoft.com/office/powerpoint/2010/main" val="1084919887"/>
+                <p14:modId xmlns:p14="http://schemas.microsoft.com/office/powerpoint/2010/main" val="1315943923"/>
               </p:ext>
             </p:extLst>
           </p:nvPr>
         </p:nvGraphicFramePr>
         <p:xfrm>
           <a:off x="508000" y="1270000"/>
-          <a:ext cx="11176000" cy="2926080"/>
+          <a:ext cx="11176000" cy="2286000"/>
         </p:xfrm>
         <a:graphic>
           <a:graphicData uri="http://schemas.openxmlformats.org/drawingml/2006/table">
@@ -14879,14 +14793,14 @@
                 <a:gridCol w="3810000">
                   <a:extLst>
                     <a:ext uri="{9D8B030D-6E8A-4147-A177-3AD203B41FA5}">
-                      <a16:colId xmlns:a16="http://schemas.microsoft.com/office/drawing/2014/main" val="2792579743"/>
+                      <a16:colId xmlns:a16="http://schemas.microsoft.com/office/drawing/2014/main" val="3524561078"/>
                     </a:ext>
                   </a:extLst>
                 </a:gridCol>
                 <a:gridCol w="7366000">
                   <a:extLst>
                     <a:ext uri="{9D8B030D-6E8A-4147-A177-3AD203B41FA5}">
-                      <a16:colId xmlns:a16="http://schemas.microsoft.com/office/drawing/2014/main" val="3436752622"/>
+                      <a16:colId xmlns:a16="http://schemas.microsoft.com/office/drawing/2014/main" val="2947185022"/>
                     </a:ext>
                   </a:extLst>
                 </a:gridCol>
@@ -14950,7 +14864,7 @@
                 </a:tc>
                 <a:extLst>
                   <a:ext uri="{0D108BD9-81ED-4DB2-BD59-A6C34878D82A}">
-                    <a16:rowId xmlns:a16="http://schemas.microsoft.com/office/drawing/2014/main" val="3843702068"/>
+                    <a16:rowId xmlns:a16="http://schemas.microsoft.com/office/drawing/2014/main" val="2594772845"/>
                   </a:ext>
                 </a:extLst>
               </a:tr>
@@ -15013,7 +14927,7 @@
                 </a:tc>
                 <a:extLst>
                   <a:ext uri="{0D108BD9-81ED-4DB2-BD59-A6C34878D82A}">
-                    <a16:rowId xmlns:a16="http://schemas.microsoft.com/office/drawing/2014/main" val="2947690391"/>
+                    <a16:rowId xmlns:a16="http://schemas.microsoft.com/office/drawing/2014/main" val="3395089353"/>
                   </a:ext>
                 </a:extLst>
               </a:tr>
@@ -15076,7 +14990,7 @@
                 </a:tc>
                 <a:extLst>
                   <a:ext uri="{0D108BD9-81ED-4DB2-BD59-A6C34878D82A}">
-                    <a16:rowId xmlns:a16="http://schemas.microsoft.com/office/drawing/2014/main" val="484574587"/>
+                    <a16:rowId xmlns:a16="http://schemas.microsoft.com/office/drawing/2014/main" val="3034366299"/>
                   </a:ext>
                 </a:extLst>
               </a:tr>
@@ -15139,7 +15053,7 @@
                 </a:tc>
                 <a:extLst>
                   <a:ext uri="{0D108BD9-81ED-4DB2-BD59-A6C34878D82A}">
-                    <a16:rowId xmlns:a16="http://schemas.microsoft.com/office/drawing/2014/main" val="2756457532"/>
+                    <a16:rowId xmlns:a16="http://schemas.microsoft.com/office/drawing/2014/main" val="4258615181"/>
                   </a:ext>
                 </a:extLst>
               </a:tr>
@@ -15202,7 +15116,7 @@
                 </a:tc>
                 <a:extLst>
                   <a:ext uri="{0D108BD9-81ED-4DB2-BD59-A6C34878D82A}">
-                    <a16:rowId xmlns:a16="http://schemas.microsoft.com/office/drawing/2014/main" val="1344735030"/>
+                    <a16:rowId xmlns:a16="http://schemas.microsoft.com/office/drawing/2014/main" val="1597651892"/>
                   </a:ext>
                 </a:extLst>
               </a:tr>
@@ -15265,7 +15179,7 @@
                 </a:tc>
                 <a:extLst>
                   <a:ext uri="{0D108BD9-81ED-4DB2-BD59-A6C34878D82A}">
-                    <a16:rowId xmlns:a16="http://schemas.microsoft.com/office/drawing/2014/main" val="3415024613"/>
+                    <a16:rowId xmlns:a16="http://schemas.microsoft.com/office/drawing/2014/main" val="890999031"/>
                   </a:ext>
                 </a:extLst>
               </a:tr>
@@ -15328,7 +15242,7 @@
                 </a:tc>
                 <a:extLst>
                   <a:ext uri="{0D108BD9-81ED-4DB2-BD59-A6C34878D82A}">
-                    <a16:rowId xmlns:a16="http://schemas.microsoft.com/office/drawing/2014/main" val="229038241"/>
+                    <a16:rowId xmlns:a16="http://schemas.microsoft.com/office/drawing/2014/main" val="136237606"/>
                   </a:ext>
                 </a:extLst>
               </a:tr>
@@ -15391,7 +15305,7 @@
                 </a:tc>
                 <a:extLst>
                   <a:ext uri="{0D108BD9-81ED-4DB2-BD59-A6C34878D82A}">
-                    <a16:rowId xmlns:a16="http://schemas.microsoft.com/office/drawing/2014/main" val="320002505"/>
+                    <a16:rowId xmlns:a16="http://schemas.microsoft.com/office/drawing/2014/main" val="1514790430"/>
                   </a:ext>
                 </a:extLst>
               </a:tr>
@@ -15454,7 +15368,7 @@
                 </a:tc>
                 <a:extLst>
                   <a:ext uri="{0D108BD9-81ED-4DB2-BD59-A6C34878D82A}">
-                    <a16:rowId xmlns:a16="http://schemas.microsoft.com/office/drawing/2014/main" val="3720341683"/>
+                    <a16:rowId xmlns:a16="http://schemas.microsoft.com/office/drawing/2014/main" val="892692488"/>
                   </a:ext>
                 </a:extLst>
               </a:tr>
@@ -15465,20 +15379,13 @@
     </p:spTree>
     <p:extLst>
       <p:ext uri="{BB962C8B-B14F-4D97-AF65-F5344CB8AC3E}">
-        <p14:creationId xmlns:p14="http://schemas.microsoft.com/office/powerpoint/2010/main" val="2772046662"/>
+        <p14:creationId xmlns:p14="http://schemas.microsoft.com/office/powerpoint/2010/main" val="1223983840"/>
       </p:ext>
     </p:extLst>
   </p:cSld>
   <p:clrMapOvr>
     <a:masterClrMapping/>
   </p:clrMapOvr>
-  <p:timing>
-    <p:tnLst>
-      <p:par>
-        <p:cTn id="1" dur="indefinite" restart="never" nodeType="tmRoot"/>
-      </p:par>
-    </p:tnLst>
-  </p:timing>
 </p:sld>
 </file>
 
@@ -16837,20 +16744,13 @@
     </p:spTree>
     <p:extLst>
       <p:ext uri="{BB962C8B-B14F-4D97-AF65-F5344CB8AC3E}">
-        <p14:creationId xmlns:p14="http://schemas.microsoft.com/office/powerpoint/2010/main" val="2936401013"/>
+        <p14:creationId xmlns:p14="http://schemas.microsoft.com/office/powerpoint/2010/main" val="622050429"/>
       </p:ext>
     </p:extLst>
   </p:cSld>
   <p:clrMapOvr>
     <a:masterClrMapping/>
   </p:clrMapOvr>
-  <p:timing>
-    <p:tnLst>
-      <p:par>
-        <p:cTn id="1" dur="indefinite" restart="never" nodeType="tmRoot"/>
-      </p:par>
-    </p:tnLst>
-  </p:timing>
 </p:sld>
 </file>
 
@@ -18627,20 +18527,13 @@
     </p:spTree>
     <p:extLst>
       <p:ext uri="{BB962C8B-B14F-4D97-AF65-F5344CB8AC3E}">
-        <p14:creationId xmlns:p14="http://schemas.microsoft.com/office/powerpoint/2010/main" val="1043214270"/>
+        <p14:creationId xmlns:p14="http://schemas.microsoft.com/office/powerpoint/2010/main" val="1924366193"/>
       </p:ext>
     </p:extLst>
   </p:cSld>
   <p:clrMapOvr>
     <a:masterClrMapping/>
   </p:clrMapOvr>
-  <p:timing>
-    <p:tnLst>
-      <p:par>
-        <p:cTn id="1" dur="indefinite" restart="never" nodeType="tmRoot"/>
-      </p:par>
-    </p:tnLst>
-  </p:timing>
 </p:sld>
 </file>
 
@@ -19799,20 +19692,13 @@
     </p:spTree>
     <p:extLst>
       <p:ext uri="{BB962C8B-B14F-4D97-AF65-F5344CB8AC3E}">
-        <p14:creationId xmlns:p14="http://schemas.microsoft.com/office/powerpoint/2010/main" val="3506992924"/>
+        <p14:creationId xmlns:p14="http://schemas.microsoft.com/office/powerpoint/2010/main" val="3100604106"/>
       </p:ext>
     </p:extLst>
   </p:cSld>
   <p:clrMapOvr>
     <a:masterClrMapping/>
   </p:clrMapOvr>
-  <p:timing>
-    <p:tnLst>
-      <p:par>
-        <p:cTn id="1" dur="indefinite" restart="never" nodeType="tmRoot"/>
-      </p:par>
-    </p:tnLst>
-  </p:timing>
 </p:sld>
 </file>
 
@@ -21062,20 +20948,13 @@
     </p:spTree>
     <p:extLst>
       <p:ext uri="{BB962C8B-B14F-4D97-AF65-F5344CB8AC3E}">
-        <p14:creationId xmlns:p14="http://schemas.microsoft.com/office/powerpoint/2010/main" val="3115294994"/>
+        <p14:creationId xmlns:p14="http://schemas.microsoft.com/office/powerpoint/2010/main" val="2756509544"/>
       </p:ext>
     </p:extLst>
   </p:cSld>
   <p:clrMapOvr>
     <a:masterClrMapping/>
   </p:clrMapOvr>
-  <p:timing>
-    <p:tnLst>
-      <p:par>
-        <p:cTn id="1" dur="indefinite" restart="never" nodeType="tmRoot"/>
-      </p:par>
-    </p:tnLst>
-  </p:timing>
 </p:sld>
 </file>
 
@@ -21644,7 +21523,7 @@
                 </a:solidFill>
                 <a:latin typeface="Segoe UI" panose="020B0502040204020203" pitchFamily="34" charset="0"/>
               </a:rPr>
-              <a:t>Lors de l'instruction d'un ticket, la personne en charge a régulièrement besoin de demander une précision ou un document à un autre collaborateur, de lui passer temporairement la main, puis de récupérer automatiquement le ticket dès que la réponse est fournie.</a:t>
+              <a:t>Lors de l'instruction d'un ticket, la personne en charge a régulièrement besoin de faire une demande d'informations supplémentaires (ou de document) à un autre collaborateur, de lui passer temporairement la main, puis de récupérer automatiquement le ticket dès que la réponse est fournie.</a:t>
             </a:r>
             <a:endParaRPr lang="en-US" sz="1250">
               <a:solidFill>
@@ -22215,20 +22094,13 @@
     </p:spTree>
     <p:extLst>
       <p:ext uri="{BB962C8B-B14F-4D97-AF65-F5344CB8AC3E}">
-        <p14:creationId xmlns:p14="http://schemas.microsoft.com/office/powerpoint/2010/main" val="2038520306"/>
+        <p14:creationId xmlns:p14="http://schemas.microsoft.com/office/powerpoint/2010/main" val="1391852104"/>
       </p:ext>
     </p:extLst>
   </p:cSld>
   <p:clrMapOvr>
     <a:masterClrMapping/>
   </p:clrMapOvr>
-  <p:timing>
-    <p:tnLst>
-      <p:par>
-        <p:cTn id="1" dur="indefinite" restart="never" nodeType="tmRoot"/>
-      </p:par>
-    </p:tnLst>
-  </p:timing>
 </p:sld>
 </file>
 
@@ -22663,15 +22535,15 @@
           <a:p>
             <a:pPr algn="ctr"/>
             <a:r>
-              <a:rPr lang="en-US" sz="1250" b="1" smtClean="0">
+              <a:rPr lang="en-US" sz="1200" b="1" smtClean="0">
                 <a:solidFill>
                   <a:srgbClr val="FFFFFF"/>
                 </a:solidFill>
                 <a:latin typeface="Segoe UI" panose="020B0502040204020203" pitchFamily="34" charset="0"/>
               </a:rPr>
-              <a:t>1. Demande</a:t>
-            </a:r>
-            <a:endParaRPr lang="en-US" sz="1250" b="1">
+              <a:t>1. Demande d'infos sup</a:t>
+            </a:r>
+            <a:endParaRPr lang="en-US" sz="1200" b="1">
               <a:solidFill>
                 <a:srgbClr val="FFFFFF"/>
               </a:solidFill>
@@ -22877,7 +22749,7 @@
           <a:p>
             <a:pPr algn="ctr"/>
             <a:r>
-              <a:rPr lang="en-US" sz="1250" b="1" smtClean="0">
+              <a:rPr lang="en-US" sz="1200" b="1" smtClean="0">
                 <a:solidFill>
                   <a:srgbClr val="FFFFFF"/>
                 </a:solidFill>
@@ -22885,7 +22757,7 @@
               </a:rPr>
               <a:t>2. Assignation</a:t>
             </a:r>
-            <a:endParaRPr lang="en-US" sz="1250" b="1">
+            <a:endParaRPr lang="en-US" sz="1200" b="1">
               <a:solidFill>
                 <a:srgbClr val="FFFFFF"/>
               </a:solidFill>
@@ -23091,7 +22963,7 @@
           <a:p>
             <a:pPr algn="ctr"/>
             <a:r>
-              <a:rPr lang="en-US" sz="1250" b="1" smtClean="0">
+              <a:rPr lang="en-US" sz="1200" b="1" smtClean="0">
                 <a:solidFill>
                   <a:srgbClr val="FFFFFF"/>
                 </a:solidFill>
@@ -23099,7 +22971,7 @@
               </a:rPr>
               <a:t>3. Réponse</a:t>
             </a:r>
-            <a:endParaRPr lang="en-US" sz="1250" b="1">
+            <a:endParaRPr lang="en-US" sz="1200" b="1">
               <a:solidFill>
                 <a:srgbClr val="FFFFFF"/>
               </a:solidFill>
@@ -23305,7 +23177,7 @@
           <a:p>
             <a:pPr algn="ctr"/>
             <a:r>
-              <a:rPr lang="en-US" sz="1250" b="1" smtClean="0">
+              <a:rPr lang="en-US" sz="1200" b="1" smtClean="0">
                 <a:solidFill>
                   <a:srgbClr val="FFFFFF"/>
                 </a:solidFill>
@@ -23313,7 +23185,7 @@
               </a:rPr>
               <a:t>4. Retour auto</a:t>
             </a:r>
-            <a:endParaRPr lang="en-US" sz="1250" b="1">
+            <a:endParaRPr lang="en-US" sz="1200" b="1">
               <a:solidFill>
                 <a:srgbClr val="FFFFFF"/>
               </a:solidFill>
@@ -23407,14 +23279,14 @@
           <p:nvPr>
             <p:extLst>
               <p:ext uri="{D42A27DB-BD31-4B8C-83A1-F6EECF244321}">
-                <p14:modId xmlns:p14="http://schemas.microsoft.com/office/powerpoint/2010/main" val="2612280425"/>
+                <p14:modId xmlns:p14="http://schemas.microsoft.com/office/powerpoint/2010/main" val="3921736268"/>
               </p:ext>
             </p:extLst>
           </p:nvPr>
         </p:nvGraphicFramePr>
         <p:xfrm>
           <a:off x="508000" y="2717800"/>
-          <a:ext cx="11176000" cy="2143760"/>
+          <a:ext cx="11176000" cy="1270000"/>
         </p:xfrm>
         <a:graphic>
           <a:graphicData uri="http://schemas.openxmlformats.org/drawingml/2006/table">
@@ -23426,21 +23298,21 @@
                 <a:gridCol w="2222500">
                   <a:extLst>
                     <a:ext uri="{9D8B030D-6E8A-4147-A177-3AD203B41FA5}">
-                      <a16:colId xmlns:a16="http://schemas.microsoft.com/office/drawing/2014/main" val="2684196024"/>
+                      <a16:colId xmlns:a16="http://schemas.microsoft.com/office/drawing/2014/main" val="2109428526"/>
                     </a:ext>
                   </a:extLst>
                 </a:gridCol>
                 <a:gridCol w="2857500">
                   <a:extLst>
                     <a:ext uri="{9D8B030D-6E8A-4147-A177-3AD203B41FA5}">
-                      <a16:colId xmlns:a16="http://schemas.microsoft.com/office/drawing/2014/main" val="73415143"/>
+                      <a16:colId xmlns:a16="http://schemas.microsoft.com/office/drawing/2014/main" val="2431741433"/>
                     </a:ext>
                   </a:extLst>
                 </a:gridCol>
                 <a:gridCol w="6096000">
                   <a:extLst>
                     <a:ext uri="{9D8B030D-6E8A-4147-A177-3AD203B41FA5}">
-                      <a16:colId xmlns:a16="http://schemas.microsoft.com/office/drawing/2014/main" val="1147609596"/>
+                      <a16:colId xmlns:a16="http://schemas.microsoft.com/office/drawing/2014/main" val="3039201553"/>
                     </a:ext>
                   </a:extLst>
                 </a:gridCol>
@@ -23532,7 +23404,7 @@
                 </a:tc>
                 <a:extLst>
                   <a:ext uri="{0D108BD9-81ED-4DB2-BD59-A6C34878D82A}">
-                    <a16:rowId xmlns:a16="http://schemas.microsoft.com/office/drawing/2014/main" val="1752508628"/>
+                    <a16:rowId xmlns:a16="http://schemas.microsoft.com/office/drawing/2014/main" val="2488301953"/>
                   </a:ext>
                 </a:extLst>
               </a:tr>
@@ -23549,7 +23421,7 @@
                           </a:solidFill>
                           <a:latin typeface="Segoe UI" panose="020B0502040204020203" pitchFamily="34" charset="0"/>
                         </a:rPr>
-                        <a:t>Demander une précision</a:t>
+                        <a:t>Demande d'infos sup</a:t>
                       </a:r>
                       <a:endParaRPr lang="en-US" sz="1100" b="1">
                         <a:solidFill>
@@ -23623,7 +23495,7 @@
                 </a:tc>
                 <a:extLst>
                   <a:ext uri="{0D108BD9-81ED-4DB2-BD59-A6C34878D82A}">
-                    <a16:rowId xmlns:a16="http://schemas.microsoft.com/office/drawing/2014/main" val="256724090"/>
+                    <a16:rowId xmlns:a16="http://schemas.microsoft.com/office/drawing/2014/main" val="443450855"/>
                   </a:ext>
                 </a:extLst>
               </a:tr>
@@ -23714,7 +23586,7 @@
                 </a:tc>
                 <a:extLst>
                   <a:ext uri="{0D108BD9-81ED-4DB2-BD59-A6C34878D82A}">
-                    <a16:rowId xmlns:a16="http://schemas.microsoft.com/office/drawing/2014/main" val="1417990755"/>
+                    <a16:rowId xmlns:a16="http://schemas.microsoft.com/office/drawing/2014/main" val="1061743104"/>
                   </a:ext>
                 </a:extLst>
               </a:tr>
@@ -23805,7 +23677,7 @@
                 </a:tc>
                 <a:extLst>
                   <a:ext uri="{0D108BD9-81ED-4DB2-BD59-A6C34878D82A}">
-                    <a16:rowId xmlns:a16="http://schemas.microsoft.com/office/drawing/2014/main" val="2337003825"/>
+                    <a16:rowId xmlns:a16="http://schemas.microsoft.com/office/drawing/2014/main" val="2642676387"/>
                   </a:ext>
                 </a:extLst>
               </a:tr>
@@ -23896,7 +23768,7 @@
                 </a:tc>
                 <a:extLst>
                   <a:ext uri="{0D108BD9-81ED-4DB2-BD59-A6C34878D82A}">
-                    <a16:rowId xmlns:a16="http://schemas.microsoft.com/office/drawing/2014/main" val="4079674591"/>
+                    <a16:rowId xmlns:a16="http://schemas.microsoft.com/office/drawing/2014/main" val="3555145789"/>
                   </a:ext>
                 </a:extLst>
               </a:tr>
@@ -23907,20 +23779,13 @@
     </p:spTree>
     <p:extLst>
       <p:ext uri="{BB962C8B-B14F-4D97-AF65-F5344CB8AC3E}">
-        <p14:creationId xmlns:p14="http://schemas.microsoft.com/office/powerpoint/2010/main" val="2608200889"/>
+        <p14:creationId xmlns:p14="http://schemas.microsoft.com/office/powerpoint/2010/main" val="1529727899"/>
       </p:ext>
     </p:extLst>
   </p:cSld>
   <p:clrMapOvr>
     <a:masterClrMapping/>
   </p:clrMapOvr>
-  <p:timing>
-    <p:tnLst>
-      <p:par>
-        <p:cTn id="1" dur="indefinite" restart="never" nodeType="tmRoot"/>
-      </p:par>
-    </p:tnLst>
-  </p:timing>
 </p:sld>
 </file>
 
@@ -24693,7 +24558,7 @@
                 </a:solidFill>
                 <a:latin typeface="Segoe UI" panose="020B0502040204020203" pitchFamily="34" charset="0"/>
               </a:rPr>
-              <a:t>Déclaration de 3 modules complémentaires : (1) web-panel « clarification-panel » injecté dans atl.jira.view.issue.right.context pour afficher le bloc à droite du ticket, (2) web-resource « clarification-resources-v3 » chargé sur le contexte jira.view.issue, et (3) rest « clarification-rest » exposé sur /clarification en version 1.0.</a:t>
+              <a:t>Déclaration de 3 modules complémentaires : (1) web-panel « panneau-demande-infos-sup » injecté dans atl.jira.view.issue.right.context pour afficher le bloc à droite du ticket, (2) web-resource « clarification-resources-v4 » chargé sur le contexte jira.view.issue, et (3) rest « clarification-rest » exposé sur /clarification en version 1.0.</a:t>
             </a:r>
             <a:endParaRPr lang="en-US" sz="1200">
               <a:solidFill>
@@ -24911,20 +24776,13 @@
     </p:spTree>
     <p:extLst>
       <p:ext uri="{BB962C8B-B14F-4D97-AF65-F5344CB8AC3E}">
-        <p14:creationId xmlns:p14="http://schemas.microsoft.com/office/powerpoint/2010/main" val="2029951525"/>
+        <p14:creationId xmlns:p14="http://schemas.microsoft.com/office/powerpoint/2010/main" val="3681749654"/>
       </p:ext>
     </p:extLst>
   </p:cSld>
   <p:clrMapOvr>
     <a:masterClrMapping/>
   </p:clrMapOvr>
-  <p:timing>
-    <p:tnLst>
-      <p:par>
-        <p:cTn id="1" dur="indefinite" restart="never" nodeType="tmRoot"/>
-      </p:par>
-    </p:tnLst>
-  </p:timing>
 </p:sld>
 </file>
 
@@ -25809,7 +25667,7 @@
                 </a:solidFill>
                 <a:latin typeface="Segoe UI" panose="020B0502040204020203" pitchFamily="34" charset="0"/>
               </a:rPr>
-              <a:t> : structure du panneau latéral et des modales AUI Dialog2 rendues côté serveur</a:t>
+              <a:t> : structure du panneau « Demandes d'informations supplémentaires » et des modales AUI Dialog2</a:t>
             </a:r>
           </a:p>
           <a:p>
@@ -25947,20 +25805,13 @@
     </p:spTree>
     <p:extLst>
       <p:ext uri="{BB962C8B-B14F-4D97-AF65-F5344CB8AC3E}">
-        <p14:creationId xmlns:p14="http://schemas.microsoft.com/office/powerpoint/2010/main" val="3140820030"/>
+        <p14:creationId xmlns:p14="http://schemas.microsoft.com/office/powerpoint/2010/main" val="3825957022"/>
       </p:ext>
     </p:extLst>
   </p:cSld>
   <p:clrMapOvr>
     <a:masterClrMapping/>
   </p:clrMapOvr>
-  <p:timing>
-    <p:tnLst>
-      <p:par>
-        <p:cTn id="1" dur="indefinite" restart="never" nodeType="tmRoot"/>
-      </p:par>
-    </p:tnLst>
-  </p:timing>
 </p:sld>
 </file>
 
@@ -26949,7 +26800,7 @@
                 </a:solidFill>
                 <a:latin typeface="Segoe UI" panose="020B0502040204020203" pitchFamily="34" charset="0"/>
               </a:rPr>
-              <a:t>Le plugin « Jira Clarification Loop » apparaît activé à chaud avec ses 3 modules (web-panel, web-resource, rest).</a:t>
+              <a:t>Le plugin apparaît activé à chaud avec ses 3 modules (panneau-demande-infos-sup, web-resource, rest).</a:t>
             </a:r>
             <a:endParaRPr lang="en-US" sz="1150">
               <a:solidFill>
@@ -27139,7 +26990,7 @@
                 </a:solidFill>
                 <a:latin typeface="Segoe UI" panose="020B0502040204020203" pitchFamily="34" charset="0"/>
               </a:rPr>
-              <a:t>« Jira Clarification Loop » activé (3 of 3 modules enabled)</a:t>
+              <a:t>Plugin activé avec ses 3 modules (3 sur 3 activés)</a:t>
             </a:r>
             <a:endParaRPr lang="en-US" sz="1300" b="1">
               <a:solidFill>
@@ -27153,20 +27004,13 @@
     </p:spTree>
     <p:extLst>
       <p:ext uri="{BB962C8B-B14F-4D97-AF65-F5344CB8AC3E}">
-        <p14:creationId xmlns:p14="http://schemas.microsoft.com/office/powerpoint/2010/main" val="48597848"/>
+        <p14:creationId xmlns:p14="http://schemas.microsoft.com/office/powerpoint/2010/main" val="3989248220"/>
       </p:ext>
     </p:extLst>
   </p:cSld>
   <p:clrMapOvr>
     <a:masterClrMapping/>
   </p:clrMapOvr>
-  <p:timing>
-    <p:tnLst>
-      <p:par>
-        <p:cTn id="1" dur="indefinite" restart="never" nodeType="tmRoot"/>
-      </p:par>
-    </p:tnLst>
-  </p:timing>
 </p:sld>
 </file>
 
@@ -27326,7 +27170,7 @@
                 </a:solidFill>
                 <a:latin typeface="Segoe UI" panose="020B0502040204020203" pitchFamily="34" charset="0"/>
               </a:rPr>
-              <a:t>Cas concret : le panneau « Demandes de précision »</a:t>
+              <a:t>Cas concret : le panneau « Demandes d'informations supplémentaires »</a:t>
             </a:r>
             <a:endParaRPr lang="en-US" sz="2400" b="1">
               <a:solidFill>
@@ -27715,7 +27559,7 @@
                 </a:solidFill>
                 <a:latin typeface="Segoe UI" panose="020B0502040204020203" pitchFamily="34" charset="0"/>
               </a:rPr>
-              <a:t> : le bouton « Demander une précision » est actif</a:t>
+              <a:t> : le bouton « Demande d'infos sup » est actif</a:t>
             </a:r>
           </a:p>
           <a:p>
@@ -27897,7 +27741,7 @@
                 </a:solidFill>
                 <a:latin typeface="Segoe UI" panose="020B0502040204020203" pitchFamily="34" charset="0"/>
               </a:rPr>
-              <a:t>Panneau « Demandes de précision » vu par l'assigné du ticket</a:t>
+              <a:t>Panneau « Demandes d'informations supplémentaires » vu par l'assigné</a:t>
             </a:r>
           </a:p>
           <a:p>
@@ -27909,7 +27753,7 @@
                 </a:solidFill>
                 <a:latin typeface="Segoe UI" panose="020B0502040204020203" pitchFamily="34" charset="0"/>
               </a:rPr>
-              <a:t>(bouton « Demander une précision » disponible)</a:t>
+              <a:t>(bouton « Demande d'infos sup » disponible)</a:t>
             </a:r>
             <a:endParaRPr lang="en-US" sz="1300" b="1">
               <a:solidFill>
@@ -27986,7 +27830,7 @@
                 </a:solidFill>
                 <a:latin typeface="Segoe UI" panose="020B0502040204020203" pitchFamily="34" charset="0"/>
               </a:rPr>
-              <a:t>Panneau « Demandes de précision » vu par un autre utilisateur :</a:t>
+              <a:t>Panneau « Demandes d'informations supplémentaires » vu par un tiers :</a:t>
             </a:r>
           </a:p>
           <a:p>
@@ -28009,83 +27853,16 @@
           </a:p>
         </p:txBody>
       </p:sp>
-      <p:pic>
-        <p:nvPicPr>
-          <p:cNvPr id="13" name="Image 12"/>
-          <p:cNvPicPr>
-            <a:picLocks noChangeAspect="1"/>
-          </p:cNvPicPr>
-          <p:nvPr/>
-        </p:nvPicPr>
-        <p:blipFill>
-          <a:blip r:embed="rId3">
-            <a:extLst>
-              <a:ext uri="{28A0092B-C50C-407E-A947-70E740481C1C}">
-                <a14:useLocalDpi xmlns:a14="http://schemas.microsoft.com/office/drawing/2010/main" val="0"/>
-              </a:ext>
-            </a:extLst>
-          </a:blip>
-          <a:stretch>
-            <a:fillRect/>
-          </a:stretch>
-        </p:blipFill>
-        <p:spPr>
-          <a:xfrm>
-            <a:off x="6366510" y="1296808"/>
-            <a:ext cx="5237480" cy="2283184"/>
-          </a:xfrm>
-          <a:prstGeom prst="rect">
-            <a:avLst/>
-          </a:prstGeom>
-        </p:spPr>
-      </p:pic>
-      <p:pic>
-        <p:nvPicPr>
-          <p:cNvPr id="14" name="Image 13"/>
-          <p:cNvPicPr>
-            <a:picLocks noChangeAspect="1"/>
-          </p:cNvPicPr>
-          <p:nvPr/>
-        </p:nvPicPr>
-        <p:blipFill>
-          <a:blip r:embed="rId4">
-            <a:extLst>
-              <a:ext uri="{28A0092B-C50C-407E-A947-70E740481C1C}">
-                <a14:useLocalDpi xmlns:a14="http://schemas.microsoft.com/office/drawing/2010/main" val="0"/>
-              </a:ext>
-            </a:extLst>
-          </a:blip>
-          <a:stretch>
-            <a:fillRect/>
-          </a:stretch>
-        </p:blipFill>
-        <p:spPr>
-          <a:xfrm>
-            <a:off x="6410960" y="3881157"/>
-            <a:ext cx="5181600" cy="2235163"/>
-          </a:xfrm>
-          <a:prstGeom prst="rect">
-            <a:avLst/>
-          </a:prstGeom>
-        </p:spPr>
-      </p:pic>
     </p:spTree>
     <p:extLst>
       <p:ext uri="{BB962C8B-B14F-4D97-AF65-F5344CB8AC3E}">
-        <p14:creationId xmlns:p14="http://schemas.microsoft.com/office/powerpoint/2010/main" val="3340307861"/>
+        <p14:creationId xmlns:p14="http://schemas.microsoft.com/office/powerpoint/2010/main" val="3234711146"/>
       </p:ext>
     </p:extLst>
   </p:cSld>
   <p:clrMapOvr>
     <a:masterClrMapping/>
   </p:clrMapOvr>
-  <p:timing>
-    <p:tnLst>
-      <p:par>
-        <p:cTn id="1" dur="indefinite" restart="never" nodeType="tmRoot"/>
-      </p:par>
-    </p:tnLst>
-  </p:timing>
 </p:sld>
 </file>
 
@@ -28245,7 +28022,7 @@
                 </a:solidFill>
                 <a:latin typeface="Segoe UI" panose="020B0502040204020203" pitchFamily="34" charset="0"/>
               </a:rPr>
-              <a:t>Cas concret : faire une demande de précision (1/2)</a:t>
+              <a:t>Cas concret : faire une demande d'infos sup (1/2)</a:t>
             </a:r>
             <a:endParaRPr lang="en-US" sz="2400" b="1">
               <a:solidFill>
@@ -28566,7 +28343,7 @@
                 </a:solidFill>
                 <a:latin typeface="Segoe UI" panose="020B0502040204020203" pitchFamily="34" charset="0"/>
               </a:rPr>
-              <a:t>Cliquer sur « Demander une précision »</a:t>
+              <a:t>Cliquer sur « Demande d'infos sup »</a:t>
             </a:r>
             <a:endParaRPr lang="en-US" sz="1400" b="1">
               <a:solidFill>
@@ -29133,7 +28910,7 @@
           <a:p>
             <a:pPr algn="ctr"/>
             <a:r>
-              <a:rPr lang="fr-FR" sz="1300" b="1" dirty="0" smtClean="0">
+              <a:rPr lang="fr-FR" sz="1300" b="1" smtClean="0">
                 <a:solidFill>
                   <a:srgbClr val="212121"/>
                 </a:solidFill>
@@ -29145,57 +28922,39 @@
           <a:p>
             <a:pPr algn="ctr"/>
             <a:r>
-              <a:rPr lang="fr-FR" sz="1300" b="1" dirty="0" smtClean="0">
+              <a:rPr lang="fr-FR" sz="1300" b="1" smtClean="0">
                 <a:solidFill>
                   <a:srgbClr val="212121"/>
                 </a:solidFill>
                 <a:latin typeface="Segoe UI" panose="020B0502040204020203" pitchFamily="34" charset="0"/>
               </a:rPr>
-              <a:t>Modale « Demander une précision » ouverte :</a:t>
+              <a:t>Modale « Demande d'informations supplémentaires » ouverte :</a:t>
             </a:r>
           </a:p>
           <a:p>
             <a:pPr algn="ctr"/>
             <a:r>
-              <a:rPr lang="fr-FR" sz="1300" b="1" dirty="0" smtClean="0">
+              <a:rPr lang="fr-FR" sz="1300" b="1" smtClean="0">
                 <a:solidFill>
                   <a:srgbClr val="212121"/>
                 </a:solidFill>
                 <a:latin typeface="Segoe UI" panose="020B0502040204020203" pitchFamily="34" charset="0"/>
               </a:rPr>
-              <a:t>Recherche globale d'utilisateur (</a:t>
-            </a:r>
-            <a:r>
-              <a:rPr lang="fr-FR" sz="1300" b="1" dirty="0" err="1" smtClean="0">
+              <a:t>Recherche globale d'utilisateur (autocomplétion),</a:t>
+            </a:r>
+          </a:p>
+          <a:p>
+            <a:pPr algn="ctr"/>
+            <a:r>
+              <a:rPr lang="fr-FR" sz="1300" b="1" smtClean="0">
                 <a:solidFill>
                   <a:srgbClr val="212121"/>
                 </a:solidFill>
                 <a:latin typeface="Segoe UI" panose="020B0502040204020203" pitchFamily="34" charset="0"/>
               </a:rPr>
-              <a:t>autocomplétion</a:t>
-            </a:r>
-            <a:r>
-              <a:rPr lang="fr-FR" sz="1300" b="1" dirty="0" smtClean="0">
-                <a:solidFill>
-                  <a:srgbClr val="212121"/>
-                </a:solidFill>
-                <a:latin typeface="Segoe UI" panose="020B0502040204020203" pitchFamily="34" charset="0"/>
-              </a:rPr>
-              <a:t>),</a:t>
-            </a:r>
-          </a:p>
-          <a:p>
-            <a:pPr algn="ctr"/>
-            <a:r>
-              <a:rPr lang="fr-FR" sz="1300" b="1" dirty="0" smtClean="0">
-                <a:solidFill>
-                  <a:srgbClr val="212121"/>
-                </a:solidFill>
-                <a:latin typeface="Segoe UI" panose="020B0502040204020203" pitchFamily="34" charset="0"/>
-              </a:rPr>
               <a:t>champ « Commentaire » et champ « Pièce jointe »</a:t>
             </a:r>
-            <a:endParaRPr lang="en-US" sz="1300" b="1" dirty="0">
+            <a:endParaRPr lang="en-US" sz="1300" b="1">
               <a:solidFill>
                 <a:srgbClr val="212121"/>
               </a:solidFill>
@@ -29293,83 +29052,16 @@
           </a:p>
         </p:txBody>
       </p:sp>
-      <p:pic>
-        <p:nvPicPr>
-          <p:cNvPr id="24" name="Image 23"/>
-          <p:cNvPicPr>
-            <a:picLocks noChangeAspect="1"/>
-          </p:cNvPicPr>
-          <p:nvPr/>
-        </p:nvPicPr>
-        <p:blipFill>
-          <a:blip r:embed="rId3">
-            <a:extLst>
-              <a:ext uri="{28A0092B-C50C-407E-A947-70E740481C1C}">
-                <a14:useLocalDpi xmlns:a14="http://schemas.microsoft.com/office/drawing/2010/main" val="0"/>
-              </a:ext>
-            </a:extLst>
-          </a:blip>
-          <a:stretch>
-            <a:fillRect/>
-          </a:stretch>
-        </p:blipFill>
-        <p:spPr>
-          <a:xfrm>
-            <a:off x="6394450" y="1308118"/>
-            <a:ext cx="5181600" cy="2235163"/>
-          </a:xfrm>
-          <a:prstGeom prst="rect">
-            <a:avLst/>
-          </a:prstGeom>
-        </p:spPr>
-      </p:pic>
-      <p:pic>
-        <p:nvPicPr>
-          <p:cNvPr id="25" name="Image 24"/>
-          <p:cNvPicPr>
-            <a:picLocks noChangeAspect="1"/>
-          </p:cNvPicPr>
-          <p:nvPr/>
-        </p:nvPicPr>
-        <p:blipFill>
-          <a:blip r:embed="rId4">
-            <a:extLst>
-              <a:ext uri="{28A0092B-C50C-407E-A947-70E740481C1C}">
-                <a14:useLocalDpi xmlns:a14="http://schemas.microsoft.com/office/drawing/2010/main" val="0"/>
-              </a:ext>
-            </a:extLst>
-          </a:blip>
-          <a:stretch>
-            <a:fillRect/>
-          </a:stretch>
-        </p:blipFill>
-        <p:spPr>
-          <a:xfrm>
-            <a:off x="6368414" y="3866634"/>
-            <a:ext cx="5233672" cy="2299732"/>
-          </a:xfrm>
-          <a:prstGeom prst="rect">
-            <a:avLst/>
-          </a:prstGeom>
-        </p:spPr>
-      </p:pic>
     </p:spTree>
     <p:extLst>
       <p:ext uri="{BB962C8B-B14F-4D97-AF65-F5344CB8AC3E}">
-        <p14:creationId xmlns:p14="http://schemas.microsoft.com/office/powerpoint/2010/main" val="1207354284"/>
+        <p14:creationId xmlns:p14="http://schemas.microsoft.com/office/powerpoint/2010/main" val="3328452087"/>
       </p:ext>
     </p:extLst>
   </p:cSld>
   <p:clrMapOvr>
     <a:masterClrMapping/>
   </p:clrMapOvr>
-  <p:timing>
-    <p:tnLst>
-      <p:par>
-        <p:cTn id="1" dur="indefinite" restart="never" nodeType="tmRoot"/>
-      </p:par>
-    </p:tnLst>
-  </p:timing>
 </p:sld>
 </file>
 
@@ -30559,83 +30251,16 @@
           </a:p>
         </p:txBody>
       </p:sp>
-      <p:pic>
-        <p:nvPicPr>
-          <p:cNvPr id="24" name="Image 23"/>
-          <p:cNvPicPr>
-            <a:picLocks noChangeAspect="1"/>
-          </p:cNvPicPr>
-          <p:nvPr/>
-        </p:nvPicPr>
-        <p:blipFill>
-          <a:blip r:embed="rId3">
-            <a:extLst>
-              <a:ext uri="{28A0092B-C50C-407E-A947-70E740481C1C}">
-                <a14:useLocalDpi xmlns:a14="http://schemas.microsoft.com/office/drawing/2010/main" val="0"/>
-              </a:ext>
-            </a:extLst>
-          </a:blip>
-          <a:stretch>
-            <a:fillRect/>
-          </a:stretch>
-        </p:blipFill>
-        <p:spPr>
-          <a:xfrm>
-            <a:off x="6358888" y="1270000"/>
-            <a:ext cx="5233672" cy="2299732"/>
-          </a:xfrm>
-          <a:prstGeom prst="rect">
-            <a:avLst/>
-          </a:prstGeom>
-        </p:spPr>
-      </p:pic>
-      <p:pic>
-        <p:nvPicPr>
-          <p:cNvPr id="25" name="Image 24"/>
-          <p:cNvPicPr>
-            <a:picLocks noChangeAspect="1"/>
-          </p:cNvPicPr>
-          <p:nvPr/>
-        </p:nvPicPr>
-        <p:blipFill>
-          <a:blip r:embed="rId4">
-            <a:extLst>
-              <a:ext uri="{28A0092B-C50C-407E-A947-70E740481C1C}">
-                <a14:useLocalDpi xmlns:a14="http://schemas.microsoft.com/office/drawing/2010/main" val="0"/>
-              </a:ext>
-            </a:extLst>
-          </a:blip>
-          <a:stretch>
-            <a:fillRect/>
-          </a:stretch>
-        </p:blipFill>
-        <p:spPr>
-          <a:xfrm>
-            <a:off x="6358888" y="3901723"/>
-            <a:ext cx="5233672" cy="2204437"/>
-          </a:xfrm>
-          <a:prstGeom prst="rect">
-            <a:avLst/>
-          </a:prstGeom>
-        </p:spPr>
-      </p:pic>
     </p:spTree>
     <p:extLst>
       <p:ext uri="{BB962C8B-B14F-4D97-AF65-F5344CB8AC3E}">
-        <p14:creationId xmlns:p14="http://schemas.microsoft.com/office/powerpoint/2010/main" val="3422339245"/>
+        <p14:creationId xmlns:p14="http://schemas.microsoft.com/office/powerpoint/2010/main" val="1303975599"/>
       </p:ext>
     </p:extLst>
   </p:cSld>
   <p:clrMapOvr>
     <a:masterClrMapping/>
   </p:clrMapOvr>
-  <p:timing>
-    <p:tnLst>
-      <p:par>
-        <p:cTn id="1" dur="indefinite" restart="never" nodeType="tmRoot"/>
-      </p:par>
-    </p:tnLst>
-  </p:timing>
 </p:sld>
 </file>
 
@@ -31020,14 +30645,14 @@
           <p:nvPr>
             <p:extLst>
               <p:ext uri="{D42A27DB-BD31-4B8C-83A1-F6EECF244321}">
-                <p14:modId xmlns:p14="http://schemas.microsoft.com/office/powerpoint/2010/main" val="3324988758"/>
+                <p14:modId xmlns:p14="http://schemas.microsoft.com/office/powerpoint/2010/main" val="1997635740"/>
               </p:ext>
             </p:extLst>
           </p:nvPr>
         </p:nvGraphicFramePr>
         <p:xfrm>
           <a:off x="508000" y="1219200"/>
-          <a:ext cx="11176000" cy="2969260"/>
+          <a:ext cx="11176000" cy="1778000"/>
         </p:xfrm>
         <a:graphic>
           <a:graphicData uri="http://schemas.openxmlformats.org/drawingml/2006/table">
@@ -31039,21 +30664,21 @@
                 <a:gridCol w="2921000">
                   <a:extLst>
                     <a:ext uri="{9D8B030D-6E8A-4147-A177-3AD203B41FA5}">
-                      <a16:colId xmlns:a16="http://schemas.microsoft.com/office/drawing/2014/main" val="1162814317"/>
+                      <a16:colId xmlns:a16="http://schemas.microsoft.com/office/drawing/2014/main" val="337232320"/>
                     </a:ext>
                   </a:extLst>
                 </a:gridCol>
                 <a:gridCol w="3937000">
                   <a:extLst>
                     <a:ext uri="{9D8B030D-6E8A-4147-A177-3AD203B41FA5}">
-                      <a16:colId xmlns:a16="http://schemas.microsoft.com/office/drawing/2014/main" val="1717120471"/>
+                      <a16:colId xmlns:a16="http://schemas.microsoft.com/office/drawing/2014/main" val="2468772794"/>
                     </a:ext>
                   </a:extLst>
                 </a:gridCol>
                 <a:gridCol w="4318000">
                   <a:extLst>
                     <a:ext uri="{9D8B030D-6E8A-4147-A177-3AD203B41FA5}">
-                      <a16:colId xmlns:a16="http://schemas.microsoft.com/office/drawing/2014/main" val="2030659894"/>
+                      <a16:colId xmlns:a16="http://schemas.microsoft.com/office/drawing/2014/main" val="2563155995"/>
                     </a:ext>
                   </a:extLst>
                 </a:gridCol>
@@ -31145,7 +30770,7 @@
                 </a:tc>
                 <a:extLst>
                   <a:ext uri="{0D108BD9-81ED-4DB2-BD59-A6C34878D82A}">
-                    <a16:rowId xmlns:a16="http://schemas.microsoft.com/office/drawing/2014/main" val="731998952"/>
+                    <a16:rowId xmlns:a16="http://schemas.microsoft.com/office/drawing/2014/main" val="2742561003"/>
                   </a:ext>
                 </a:extLst>
               </a:tr>
@@ -31236,7 +30861,7 @@
                 </a:tc>
                 <a:extLst>
                   <a:ext uri="{0D108BD9-81ED-4DB2-BD59-A6C34878D82A}">
-                    <a16:rowId xmlns:a16="http://schemas.microsoft.com/office/drawing/2014/main" val="2040365074"/>
+                    <a16:rowId xmlns:a16="http://schemas.microsoft.com/office/drawing/2014/main" val="2098894487"/>
                   </a:ext>
                 </a:extLst>
               </a:tr>
@@ -31327,7 +30952,7 @@
                 </a:tc>
                 <a:extLst>
                   <a:ext uri="{0D108BD9-81ED-4DB2-BD59-A6C34878D82A}">
-                    <a16:rowId xmlns:a16="http://schemas.microsoft.com/office/drawing/2014/main" val="937056335"/>
+                    <a16:rowId xmlns:a16="http://schemas.microsoft.com/office/drawing/2014/main" val="1535865118"/>
                   </a:ext>
                 </a:extLst>
               </a:tr>
@@ -31418,7 +31043,7 @@
                 </a:tc>
                 <a:extLst>
                   <a:ext uri="{0D108BD9-81ED-4DB2-BD59-A6C34878D82A}">
-                    <a16:rowId xmlns:a16="http://schemas.microsoft.com/office/drawing/2014/main" val="3429020633"/>
+                    <a16:rowId xmlns:a16="http://schemas.microsoft.com/office/drawing/2014/main" val="2583370523"/>
                   </a:ext>
                 </a:extLst>
               </a:tr>
@@ -31509,7 +31134,7 @@
                 </a:tc>
                 <a:extLst>
                   <a:ext uri="{0D108BD9-81ED-4DB2-BD59-A6C34878D82A}">
-                    <a16:rowId xmlns:a16="http://schemas.microsoft.com/office/drawing/2014/main" val="1093182009"/>
+                    <a16:rowId xmlns:a16="http://schemas.microsoft.com/office/drawing/2014/main" val="3473592581"/>
                   </a:ext>
                 </a:extLst>
               </a:tr>
@@ -31600,7 +31225,7 @@
                 </a:tc>
                 <a:extLst>
                   <a:ext uri="{0D108BD9-81ED-4DB2-BD59-A6C34878D82A}">
-                    <a16:rowId xmlns:a16="http://schemas.microsoft.com/office/drawing/2014/main" val="719700197"/>
+                    <a16:rowId xmlns:a16="http://schemas.microsoft.com/office/drawing/2014/main" val="563019663"/>
                   </a:ext>
                 </a:extLst>
               </a:tr>
@@ -31691,7 +31316,7 @@
                 </a:tc>
                 <a:extLst>
                   <a:ext uri="{0D108BD9-81ED-4DB2-BD59-A6C34878D82A}">
-                    <a16:rowId xmlns:a16="http://schemas.microsoft.com/office/drawing/2014/main" val="3503509127"/>
+                    <a16:rowId xmlns:a16="http://schemas.microsoft.com/office/drawing/2014/main" val="1311198970"/>
                   </a:ext>
                 </a:extLst>
               </a:tr>
@@ -31702,20 +31327,13 @@
     </p:spTree>
     <p:extLst>
       <p:ext uri="{BB962C8B-B14F-4D97-AF65-F5344CB8AC3E}">
-        <p14:creationId xmlns:p14="http://schemas.microsoft.com/office/powerpoint/2010/main" val="1745018295"/>
+        <p14:creationId xmlns:p14="http://schemas.microsoft.com/office/powerpoint/2010/main" val="781130328"/>
       </p:ext>
     </p:extLst>
   </p:cSld>
   <p:clrMapOvr>
     <a:masterClrMapping/>
   </p:clrMapOvr>
-  <p:timing>
-    <p:tnLst>
-      <p:par>
-        <p:cTn id="1" dur="indefinite" restart="never" nodeType="tmRoot"/>
-      </p:par>
-    </p:tnLst>
-  </p:timing>
 </p:sld>
 </file>
 
@@ -32890,20 +32508,13 @@
     </p:spTree>
     <p:extLst>
       <p:ext uri="{BB962C8B-B14F-4D97-AF65-F5344CB8AC3E}">
-        <p14:creationId xmlns:p14="http://schemas.microsoft.com/office/powerpoint/2010/main" val="452047732"/>
+        <p14:creationId xmlns:p14="http://schemas.microsoft.com/office/powerpoint/2010/main" val="282037528"/>
       </p:ext>
     </p:extLst>
   </p:cSld>
   <p:clrMapOvr>
     <a:masterClrMapping/>
   </p:clrMapOvr>
-  <p:timing>
-    <p:tnLst>
-      <p:par>
-        <p:cTn id="1" dur="indefinite" restart="never" nodeType="tmRoot"/>
-      </p:par>
-    </p:tnLst>
-  </p:timing>
 </p:sld>
 </file>
 
@@ -34417,20 +34028,13 @@
     </p:spTree>
     <p:extLst>
       <p:ext uri="{BB962C8B-B14F-4D97-AF65-F5344CB8AC3E}">
-        <p14:creationId xmlns:p14="http://schemas.microsoft.com/office/powerpoint/2010/main" val="2323855060"/>
+        <p14:creationId xmlns:p14="http://schemas.microsoft.com/office/powerpoint/2010/main" val="4172842446"/>
       </p:ext>
     </p:extLst>
   </p:cSld>
   <p:clrMapOvr>
     <a:masterClrMapping/>
   </p:clrMapOvr>
-  <p:timing>
-    <p:tnLst>
-      <p:par>
-        <p:cTn id="1" dur="indefinite" restart="never" nodeType="tmRoot"/>
-      </p:par>
-    </p:tnLst>
-  </p:timing>
 </p:sld>
 </file>
 
@@ -34834,20 +34438,13 @@
     </p:spTree>
     <p:extLst>
       <p:ext uri="{BB962C8B-B14F-4D97-AF65-F5344CB8AC3E}">
-        <p14:creationId xmlns:p14="http://schemas.microsoft.com/office/powerpoint/2010/main" val="15338453"/>
+        <p14:creationId xmlns:p14="http://schemas.microsoft.com/office/powerpoint/2010/main" val="2645660564"/>
       </p:ext>
     </p:extLst>
   </p:cSld>
   <p:clrMapOvr>
     <a:masterClrMapping/>
   </p:clrMapOvr>
-  <p:timing>
-    <p:tnLst>
-      <p:par>
-        <p:cTn id="1" dur="indefinite" restart="never" nodeType="tmRoot"/>
-      </p:par>
-    </p:tnLst>
-  </p:timing>
 </p:sld>
 </file>
 
@@ -36266,20 +35863,13 @@
     </p:spTree>
     <p:extLst>
       <p:ext uri="{BB962C8B-B14F-4D97-AF65-F5344CB8AC3E}">
-        <p14:creationId xmlns:p14="http://schemas.microsoft.com/office/powerpoint/2010/main" val="1104775362"/>
+        <p14:creationId xmlns:p14="http://schemas.microsoft.com/office/powerpoint/2010/main" val="395997090"/>
       </p:ext>
     </p:extLst>
   </p:cSld>
   <p:clrMapOvr>
     <a:masterClrMapping/>
   </p:clrMapOvr>
-  <p:timing>
-    <p:tnLst>
-      <p:par>
-        <p:cTn id="1" dur="indefinite" restart="never" nodeType="tmRoot"/>
-      </p:par>
-    </p:tnLst>
-  </p:timing>
 </p:sld>
 </file>
 
@@ -37522,20 +37112,13 @@
     </p:spTree>
     <p:extLst>
       <p:ext uri="{BB962C8B-B14F-4D97-AF65-F5344CB8AC3E}">
-        <p14:creationId xmlns:p14="http://schemas.microsoft.com/office/powerpoint/2010/main" val="1292674875"/>
+        <p14:creationId xmlns:p14="http://schemas.microsoft.com/office/powerpoint/2010/main" val="407864973"/>
       </p:ext>
     </p:extLst>
   </p:cSld>
   <p:clrMapOvr>
     <a:masterClrMapping/>
   </p:clrMapOvr>
-  <p:timing>
-    <p:tnLst>
-      <p:par>
-        <p:cTn id="1" dur="indefinite" restart="never" nodeType="tmRoot"/>
-      </p:par>
-    </p:tnLst>
-  </p:timing>
 </p:sld>
 </file>
 
@@ -38829,20 +38412,13 @@
     </p:spTree>
     <p:extLst>
       <p:ext uri="{BB962C8B-B14F-4D97-AF65-F5344CB8AC3E}">
-        <p14:creationId xmlns:p14="http://schemas.microsoft.com/office/powerpoint/2010/main" val="3385322829"/>
+        <p14:creationId xmlns:p14="http://schemas.microsoft.com/office/powerpoint/2010/main" val="1414665423"/>
       </p:ext>
     </p:extLst>
   </p:cSld>
   <p:clrMapOvr>
     <a:masterClrMapping/>
   </p:clrMapOvr>
-  <p:timing>
-    <p:tnLst>
-      <p:par>
-        <p:cTn id="1" dur="indefinite" restart="never" nodeType="tmRoot"/>
-      </p:par>
-    </p:tnLst>
-  </p:timing>
 </p:sld>
 </file>
 
@@ -40901,20 +40477,13 @@
     </p:spTree>
     <p:extLst>
       <p:ext uri="{BB962C8B-B14F-4D97-AF65-F5344CB8AC3E}">
-        <p14:creationId xmlns:p14="http://schemas.microsoft.com/office/powerpoint/2010/main" val="214534102"/>
+        <p14:creationId xmlns:p14="http://schemas.microsoft.com/office/powerpoint/2010/main" val="1513699788"/>
       </p:ext>
     </p:extLst>
   </p:cSld>
   <p:clrMapOvr>
     <a:masterClrMapping/>
   </p:clrMapOvr>
-  <p:timing>
-    <p:tnLst>
-      <p:par>
-        <p:cTn id="1" dur="indefinite" restart="never" nodeType="tmRoot"/>
-      </p:par>
-    </p:tnLst>
-  </p:timing>
 </p:sld>
 </file>
 
@@ -42648,20 +42217,13 @@
     </p:spTree>
     <p:extLst>
       <p:ext uri="{BB962C8B-B14F-4D97-AF65-F5344CB8AC3E}">
-        <p14:creationId xmlns:p14="http://schemas.microsoft.com/office/powerpoint/2010/main" val="2793149916"/>
+        <p14:creationId xmlns:p14="http://schemas.microsoft.com/office/powerpoint/2010/main" val="2403262003"/>
       </p:ext>
     </p:extLst>
   </p:cSld>
   <p:clrMapOvr>
     <a:masterClrMapping/>
   </p:clrMapOvr>
-  <p:timing>
-    <p:tnLst>
-      <p:par>
-        <p:cTn id="1" dur="indefinite" restart="never" nodeType="tmRoot"/>
-      </p:par>
-    </p:tnLst>
-  </p:timing>
 </p:sld>
 </file>
 
@@ -44426,20 +43988,13 @@
     </p:spTree>
     <p:extLst>
       <p:ext uri="{BB962C8B-B14F-4D97-AF65-F5344CB8AC3E}">
-        <p14:creationId xmlns:p14="http://schemas.microsoft.com/office/powerpoint/2010/main" val="1508109557"/>
+        <p14:creationId xmlns:p14="http://schemas.microsoft.com/office/powerpoint/2010/main" val="43569648"/>
       </p:ext>
     </p:extLst>
   </p:cSld>
   <p:clrMapOvr>
     <a:masterClrMapping/>
   </p:clrMapOvr>
-  <p:timing>
-    <p:tnLst>
-      <p:par>
-        <p:cTn id="1" dur="indefinite" restart="never" nodeType="tmRoot"/>
-      </p:par>
-    </p:tnLst>
-  </p:timing>
 </p:sld>
 </file>
 

</xml_diff>